<commit_message>
build(deck): package portable presentation
</commit_message>
<xml_diff>
--- a/outputs/imp-lesion-evidence-defense.pptx
+++ b/outputs/imp-lesion-evidence-defense.pptx
@@ -2,24 +2,24 @@
 <file path=ppt/presentation.xml><?xml version="1.0" encoding="utf-8"?>
 <p:presentation xmlns:p="http://schemas.openxmlformats.org/presentationml/2006/main">
   <p:sldMasterIdLst>
-    <p:sldMasterId xmlns:r="http://schemas.openxmlformats.org/officeDocument/2006/relationships" id="2147483648" r:id="R0b829eadb5c34220"/>
+    <p:sldMasterId xmlns:r="http://schemas.openxmlformats.org/officeDocument/2006/relationships" id="2147483648" r:id="R1781e8bd78984d52"/>
   </p:sldMasterIdLst>
   <p:notesMasterIdLst>
-    <p:notesMasterId xmlns:r="http://schemas.openxmlformats.org/officeDocument/2006/relationships" r:id="Ra79fa28d4bd346ac"/>
+    <p:notesMasterId xmlns:r="http://schemas.openxmlformats.org/officeDocument/2006/relationships" r:id="Rf4b6414764ba4986"/>
   </p:notesMasterIdLst>
   <p:sldIdLst>
-    <p:sldId xmlns:r="http://schemas.openxmlformats.org/officeDocument/2006/relationships" id="256" r:id="R3fec2a4d372e4d48"/>
-    <p:sldId xmlns:r="http://schemas.openxmlformats.org/officeDocument/2006/relationships" id="257" r:id="Rcdd5d9f0853a4acf"/>
-    <p:sldId xmlns:r="http://schemas.openxmlformats.org/officeDocument/2006/relationships" id="258" r:id="R3baa08e27c734ddd"/>
-    <p:sldId xmlns:r="http://schemas.openxmlformats.org/officeDocument/2006/relationships" id="259" r:id="R63ecf0b6aac34e4c"/>
-    <p:sldId xmlns:r="http://schemas.openxmlformats.org/officeDocument/2006/relationships" id="260" r:id="Rd534d54cb84f4f8c"/>
-    <p:sldId xmlns:r="http://schemas.openxmlformats.org/officeDocument/2006/relationships" id="261" r:id="R25f049441d94489e"/>
-    <p:sldId xmlns:r="http://schemas.openxmlformats.org/officeDocument/2006/relationships" id="262" r:id="R78268f1f3bca4677"/>
-    <p:sldId xmlns:r="http://schemas.openxmlformats.org/officeDocument/2006/relationships" id="263" r:id="R14e7d7ae6f1c4bc8"/>
-    <p:sldId xmlns:r="http://schemas.openxmlformats.org/officeDocument/2006/relationships" id="264" r:id="Rc106b04a2e2a49ad"/>
-    <p:sldId xmlns:r="http://schemas.openxmlformats.org/officeDocument/2006/relationships" id="265" r:id="R4e1f201f81b54d99"/>
-    <p:sldId xmlns:r="http://schemas.openxmlformats.org/officeDocument/2006/relationships" id="266" r:id="Rbdb9c8b53a584771"/>
-    <p:sldId xmlns:r="http://schemas.openxmlformats.org/officeDocument/2006/relationships" id="267" r:id="R6e9f54a7a8d2412c"/>
+    <p:sldId xmlns:r="http://schemas.openxmlformats.org/officeDocument/2006/relationships" id="256" r:id="Re8effcde9d7c44cc"/>
+    <p:sldId xmlns:r="http://schemas.openxmlformats.org/officeDocument/2006/relationships" id="257" r:id="R0e303cf76ceb4843"/>
+    <p:sldId xmlns:r="http://schemas.openxmlformats.org/officeDocument/2006/relationships" id="258" r:id="R6da07be671b247be"/>
+    <p:sldId xmlns:r="http://schemas.openxmlformats.org/officeDocument/2006/relationships" id="259" r:id="Rb03c315dd7fa4051"/>
+    <p:sldId xmlns:r="http://schemas.openxmlformats.org/officeDocument/2006/relationships" id="260" r:id="R2cf0a0f349d74dc0"/>
+    <p:sldId xmlns:r="http://schemas.openxmlformats.org/officeDocument/2006/relationships" id="261" r:id="Re9c0d6c207ed43cc"/>
+    <p:sldId xmlns:r="http://schemas.openxmlformats.org/officeDocument/2006/relationships" id="262" r:id="R5841e9e7076a4616"/>
+    <p:sldId xmlns:r="http://schemas.openxmlformats.org/officeDocument/2006/relationships" id="263" r:id="Rdf6987adcb384564"/>
+    <p:sldId xmlns:r="http://schemas.openxmlformats.org/officeDocument/2006/relationships" id="264" r:id="R70881238fdf64810"/>
+    <p:sldId xmlns:r="http://schemas.openxmlformats.org/officeDocument/2006/relationships" id="265" r:id="R8f179fbe3cf74404"/>
+    <p:sldId xmlns:r="http://schemas.openxmlformats.org/officeDocument/2006/relationships" id="266" r:id="R0787a4b96d4b42e7"/>
+    <p:sldId xmlns:r="http://schemas.openxmlformats.org/officeDocument/2006/relationships" id="267" r:id="R66c00564d7164d5d"/>
   </p:sldIdLst>
   <p:sldSz cx="12192000" cy="6858000"/>
   <p:notesSz cx="6858000" cy="9144000"/>
@@ -1506,7 +1506,7 @@
   </p:cSld>
   <p:clrMap bg1="lt1" tx1="dk1" bg2="lt2" tx2="dk2" accent1="accent1" accent2="accent2" accent3="accent3" accent4="accent4" accent5="accent5" accent6="accent6" hlink="hlink" folHlink="folHlink"/>
   <p:sldLayoutIdLst>
-    <p:sldLayoutId xmlns:r="http://schemas.openxmlformats.org/officeDocument/2006/relationships" id="2147483649" r:id="Re2d36afe19c34155"/>
+    <p:sldLayoutId xmlns:r="http://schemas.openxmlformats.org/officeDocument/2006/relationships" id="2147483649" r:id="R738b11c5222f400f"/>
   </p:sldLayoutIdLst>
   <p:txStyles>
     <p:titleStyle>
@@ -2057,7 +2057,7 @@
           <p:cNvPr id="11" name="title-rust-field">
             <a:extLst xmlns:a="http://schemas.openxmlformats.org/drawingml/2006/main">
               <a:ext uri="{FF2B5EF4-FFF2-40B4-BE49-F238E27FC236}">
-                <a16:creationId xmlns:a16="http://schemas.microsoft.com/office/drawing/2014/main" id="{349B5ECC-00DA-49EE-B9B7-F78057AF63BB}"/>
+                <a16:creationId xmlns:a16="http://schemas.microsoft.com/office/drawing/2014/main" id="{88FFAB6C-3CBE-479E-8D60-3E16F234E901}"/>
               </a:ext>
             </a:extLst>
           </p:cNvPr>
@@ -2088,7 +2088,7 @@
           <p:cNvPr id="2" name="title-teal-field">
             <a:extLst xmlns:a="http://schemas.openxmlformats.org/drawingml/2006/main">
               <a:ext uri="{FF2B5EF4-FFF2-40B4-BE49-F238E27FC236}">
-                <a16:creationId xmlns:a16="http://schemas.microsoft.com/office/drawing/2014/main" id="{43D53898-32B6-4CBC-8358-10B043B4F06A}"/>
+                <a16:creationId xmlns:a16="http://schemas.microsoft.com/office/drawing/2014/main" id="{D46AD3FA-7635-48F2-B435-D40A75FBBD3B}"/>
               </a:ext>
             </a:extLst>
           </p:cNvPr>
@@ -2119,7 +2119,7 @@
           <p:cNvPr id="3" name="title-kicker">
             <a:extLst xmlns:a="http://schemas.openxmlformats.org/drawingml/2006/main">
               <a:ext uri="{FF2B5EF4-FFF2-40B4-BE49-F238E27FC236}">
-                <a16:creationId xmlns:a16="http://schemas.microsoft.com/office/drawing/2014/main" id="{74FDA81D-261A-48A0-8CA3-CDCB8B9B35C4}"/>
+                <a16:creationId xmlns:a16="http://schemas.microsoft.com/office/drawing/2014/main" id="{CF8198FC-896A-424A-8401-524B848D3A09}"/>
               </a:ext>
             </a:extLst>
           </p:cNvPr>
@@ -2169,7 +2169,7 @@
           <p:cNvPr id="4" name="title-main">
             <a:extLst xmlns:a="http://schemas.openxmlformats.org/drawingml/2006/main">
               <a:ext uri="{FF2B5EF4-FFF2-40B4-BE49-F238E27FC236}">
-                <a16:creationId xmlns:a16="http://schemas.microsoft.com/office/drawing/2014/main" id="{E2ADA34A-E238-42CF-84F5-26499BF2C176}"/>
+                <a16:creationId xmlns:a16="http://schemas.microsoft.com/office/drawing/2014/main" id="{8790B5FA-035D-4BB5-9413-207A9C798E86}"/>
               </a:ext>
             </a:extLst>
           </p:cNvPr>
@@ -2219,7 +2219,7 @@
           <p:cNvPr id="5" name="title-claim">
             <a:extLst xmlns:a="http://schemas.openxmlformats.org/drawingml/2006/main">
               <a:ext uri="{FF2B5EF4-FFF2-40B4-BE49-F238E27FC236}">
-                <a16:creationId xmlns:a16="http://schemas.microsoft.com/office/drawing/2014/main" id="{9E34F19F-4606-43F5-B1DF-3FEB1B3834AE}"/>
+                <a16:creationId xmlns:a16="http://schemas.microsoft.com/office/drawing/2014/main" id="{5F9FFAF9-DA34-4D12-8792-7B3325592697}"/>
               </a:ext>
             </a:extLst>
           </p:cNvPr>
@@ -2269,7 +2269,7 @@
           <p:cNvPr id="6" name="title-rule">
             <a:extLst xmlns:a="http://schemas.openxmlformats.org/drawingml/2006/main">
               <a:ext uri="{FF2B5EF4-FFF2-40B4-BE49-F238E27FC236}">
-                <a16:creationId xmlns:a16="http://schemas.microsoft.com/office/drawing/2014/main" id="{6716ABBB-D0A7-45EF-BF56-C6A1BD9D1F99}"/>
+                <a16:creationId xmlns:a16="http://schemas.microsoft.com/office/drawing/2014/main" id="{A24EBF0A-E39C-4B15-9D9B-8C9266BF9AD1}"/>
               </a:ext>
             </a:extLst>
           </p:cNvPr>
@@ -2300,7 +2300,7 @@
           <p:cNvPr id="7" name="title-baseline">
             <a:extLst xmlns:a="http://schemas.openxmlformats.org/drawingml/2006/main">
               <a:ext uri="{FF2B5EF4-FFF2-40B4-BE49-F238E27FC236}">
-                <a16:creationId xmlns:a16="http://schemas.microsoft.com/office/drawing/2014/main" id="{A0A049F1-0D80-49AC-9994-7134BA304FA9}"/>
+                <a16:creationId xmlns:a16="http://schemas.microsoft.com/office/drawing/2014/main" id="{321F0F39-7080-4B98-AC22-4098813C2901}"/>
               </a:ext>
             </a:extLst>
           </p:cNvPr>
@@ -2350,7 +2350,7 @@
           <p:cNvPr id="8" name="title-boundary">
             <a:extLst xmlns:a="http://schemas.openxmlformats.org/drawingml/2006/main">
               <a:ext uri="{FF2B5EF4-FFF2-40B4-BE49-F238E27FC236}">
-                <a16:creationId xmlns:a16="http://schemas.microsoft.com/office/drawing/2014/main" id="{B9C46512-BAB5-4A2A-A9FD-A2F0038DA71B}"/>
+                <a16:creationId xmlns:a16="http://schemas.microsoft.com/office/drawing/2014/main" id="{1805C26F-4BA3-4F66-A322-85BA6A41E180}"/>
               </a:ext>
             </a:extLst>
           </p:cNvPr>
@@ -2417,7 +2417,7 @@
           <p:cNvPr id="9" name="title-atlas">
             <a:extLst xmlns:a="http://schemas.openxmlformats.org/drawingml/2006/main">
               <a:ext uri="{FF2B5EF4-FFF2-40B4-BE49-F238E27FC236}">
-                <a16:creationId xmlns:a16="http://schemas.microsoft.com/office/drawing/2014/main" id="{6EFAD410-4A18-4AEF-8B53-922DF041FAA4}"/>
+                <a16:creationId xmlns:a16="http://schemas.microsoft.com/office/drawing/2014/main" id="{77654E65-5939-4AC3-A9B6-3E10F0A1D35A}"/>
               </a:ext>
             </a:extLst>
           </p:cNvPr>
@@ -2484,7 +2484,7 @@
           <p:cNvPr id="10" name="title-meta">
             <a:extLst xmlns:a="http://schemas.openxmlformats.org/drawingml/2006/main">
               <a:ext uri="{FF2B5EF4-FFF2-40B4-BE49-F238E27FC236}">
-                <a16:creationId xmlns:a16="http://schemas.microsoft.com/office/drawing/2014/main" id="{0097C2B1-D7D0-42DB-862F-7B9DABC8B47E}"/>
+                <a16:creationId xmlns:a16="http://schemas.microsoft.com/office/drawing/2014/main" id="{34C5649F-8412-41E2-9CEF-E1A289C2F10F}"/>
               </a:ext>
             </a:extLst>
           </p:cNvPr>
@@ -2532,7 +2532,7 @@
     </p:spTree>
     <p:extLst>
       <p:ext uri="{BB962C8B-B14F-4D97-AF65-F5344CB8AC3E}">
-        <p14:creationId xmlns:p14="http://schemas.microsoft.com/office/powerpoint/2010/main" val="703529926"/>
+        <p14:creationId xmlns:p14="http://schemas.microsoft.com/office/powerpoint/2010/main" val="2013735485"/>
       </p:ext>
     </p:extLst>
   </p:cSld>
@@ -2563,7 +2563,7 @@
           <p:cNvPr id="15" name="top-rule-10">
             <a:extLst xmlns:a="http://schemas.openxmlformats.org/drawingml/2006/main">
               <a:ext uri="{FF2B5EF4-FFF2-40B4-BE49-F238E27FC236}">
-                <a16:creationId xmlns:a16="http://schemas.microsoft.com/office/drawing/2014/main" id="{83C21AEA-5D26-415F-8725-D559DC91506D}"/>
+                <a16:creationId xmlns:a16="http://schemas.microsoft.com/office/drawing/2014/main" id="{0773C0BF-4DEB-4A9C-A463-81BEE37776E3}"/>
               </a:ext>
             </a:extLst>
           </p:cNvPr>
@@ -2594,7 +2594,7 @@
           <p:cNvPr id="2" name="kicker-10">
             <a:extLst xmlns:a="http://schemas.openxmlformats.org/drawingml/2006/main">
               <a:ext uri="{FF2B5EF4-FFF2-40B4-BE49-F238E27FC236}">
-                <a16:creationId xmlns:a16="http://schemas.microsoft.com/office/drawing/2014/main" id="{4D52639F-00E0-4731-BEFD-A7A0A382389E}"/>
+                <a16:creationId xmlns:a16="http://schemas.microsoft.com/office/drawing/2014/main" id="{69DBA1F0-21AC-4D0D-8B6C-B122DC09DD98}"/>
               </a:ext>
             </a:extLst>
           </p:cNvPr>
@@ -2644,7 +2644,7 @@
           <p:cNvPr id="3" name="slide-title-10">
             <a:extLst xmlns:a="http://schemas.openxmlformats.org/drawingml/2006/main">
               <a:ext uri="{FF2B5EF4-FFF2-40B4-BE49-F238E27FC236}">
-                <a16:creationId xmlns:a16="http://schemas.microsoft.com/office/drawing/2014/main" id="{375CA50D-25F0-4703-9813-4D35FBD20F5F}"/>
+                <a16:creationId xmlns:a16="http://schemas.microsoft.com/office/drawing/2014/main" id="{98EF2A2D-B3D9-46F5-86C9-7CF25154BA17}"/>
               </a:ext>
             </a:extLst>
           </p:cNvPr>
@@ -2694,7 +2694,7 @@
           <p:cNvPr id="4" name="footer-rule-10">
             <a:extLst xmlns:a="http://schemas.openxmlformats.org/drawingml/2006/main">
               <a:ext uri="{FF2B5EF4-FFF2-40B4-BE49-F238E27FC236}">
-                <a16:creationId xmlns:a16="http://schemas.microsoft.com/office/drawing/2014/main" id="{F5A1CDDE-6360-4277-91DA-14B37511FEB3}"/>
+                <a16:creationId xmlns:a16="http://schemas.microsoft.com/office/drawing/2014/main" id="{976C7B81-1C2F-4928-8C7B-922E5EDA2424}"/>
               </a:ext>
             </a:extLst>
           </p:cNvPr>
@@ -2725,7 +2725,7 @@
           <p:cNvPr id="5" name="evidence-10">
             <a:extLst xmlns:a="http://schemas.openxmlformats.org/drawingml/2006/main">
               <a:ext uri="{FF2B5EF4-FFF2-40B4-BE49-F238E27FC236}">
-                <a16:creationId xmlns:a16="http://schemas.microsoft.com/office/drawing/2014/main" id="{EA62CF92-6C37-4EDE-8E2B-A8119CDEA41C}"/>
+                <a16:creationId xmlns:a16="http://schemas.microsoft.com/office/drawing/2014/main" id="{CF3E6AFF-6466-4218-92C6-BBDC09E60809}"/>
               </a:ext>
             </a:extLst>
           </p:cNvPr>
@@ -2775,7 +2775,7 @@
           <p:cNvPr id="6" name="page-10">
             <a:extLst xmlns:a="http://schemas.openxmlformats.org/drawingml/2006/main">
               <a:ext uri="{FF2B5EF4-FFF2-40B4-BE49-F238E27FC236}">
-                <a16:creationId xmlns:a16="http://schemas.microsoft.com/office/drawing/2014/main" id="{790636CA-9B18-4AB6-8602-4F670D5C314B}"/>
+                <a16:creationId xmlns:a16="http://schemas.microsoft.com/office/drawing/2014/main" id="{C2C29E0C-C525-4F4B-B98E-76A47E4A3BD4}"/>
               </a:ext>
             </a:extLst>
           </p:cNvPr>
@@ -2825,7 +2825,7 @@
           <p:cNvPr id="7" name="s10-demo-claim-mark">
             <a:extLst xmlns:a="http://schemas.openxmlformats.org/drawingml/2006/main">
               <a:ext uri="{FF2B5EF4-FFF2-40B4-BE49-F238E27FC236}">
-                <a16:creationId xmlns:a16="http://schemas.microsoft.com/office/drawing/2014/main" id="{CC9F6853-42DB-4C79-BE18-3832AA8DDF71}"/>
+                <a16:creationId xmlns:a16="http://schemas.microsoft.com/office/drawing/2014/main" id="{BB848692-0B54-48B5-A019-F41FD9E01CD7}"/>
               </a:ext>
             </a:extLst>
           </p:cNvPr>
@@ -2856,7 +2856,7 @@
           <p:cNvPr id="8" name="s10-demo-claim">
             <a:extLst xmlns:a="http://schemas.openxmlformats.org/drawingml/2006/main">
               <a:ext uri="{FF2B5EF4-FFF2-40B4-BE49-F238E27FC236}">
-                <a16:creationId xmlns:a16="http://schemas.microsoft.com/office/drawing/2014/main" id="{A1DBA6F7-F306-4E62-BD43-8DFF1221EDCC}"/>
+                <a16:creationId xmlns:a16="http://schemas.microsoft.com/office/drawing/2014/main" id="{98FCB334-6288-434E-A69A-CE6A9CA648C5}"/>
               </a:ext>
             </a:extLst>
           </p:cNvPr>
@@ -2910,7 +2910,7 @@
           <p:nvPr/>
         </p:nvPicPr>
         <p:blipFill>
-          <a:blip xmlns:r="http://schemas.openxmlformats.org/officeDocument/2006/relationships" xmlns:a="http://schemas.openxmlformats.org/drawingml/2006/main" r:embed="Rf03bb088bbcf45ef"/>
+          <a:blip xmlns:r="http://schemas.openxmlformats.org/officeDocument/2006/relationships" xmlns:a="http://schemas.openxmlformats.org/drawingml/2006/main" r:embed="R29593d2356cf4c75"/>
           <a:stretch xmlns:a="http://schemas.openxmlformats.org/drawingml/2006/main"/>
         </p:blipFill>
         <p:spPr>
@@ -2928,7 +2928,7 @@
           <p:cNvPr id="10" name="demo-parity">
             <a:extLst xmlns:a="http://schemas.openxmlformats.org/drawingml/2006/main">
               <a:ext uri="{FF2B5EF4-FFF2-40B4-BE49-F238E27FC236}">
-                <a16:creationId xmlns:a16="http://schemas.microsoft.com/office/drawing/2014/main" id="{9DE7D875-6339-40BA-A881-D446E4F6FFAC}"/>
+                <a16:creationId xmlns:a16="http://schemas.microsoft.com/office/drawing/2014/main" id="{92C09A44-D055-476B-A5E3-DB7CD4E87DFB}"/>
               </a:ext>
             </a:extLst>
           </p:cNvPr>
@@ -2978,7 +2978,7 @@
           <p:cNvPr id="11" name="demo-parity-label">
             <a:extLst xmlns:a="http://schemas.openxmlformats.org/drawingml/2006/main">
               <a:ext uri="{FF2B5EF4-FFF2-40B4-BE49-F238E27FC236}">
-                <a16:creationId xmlns:a16="http://schemas.microsoft.com/office/drawing/2014/main" id="{753918F4-28B7-4B4C-82C1-3956A23B0DFD}"/>
+                <a16:creationId xmlns:a16="http://schemas.microsoft.com/office/drawing/2014/main" id="{6EBD55D1-70BC-4E5F-BC09-84376E21E297}"/>
               </a:ext>
             </a:extLst>
           </p:cNvPr>
@@ -3028,7 +3028,7 @@
           <p:cNvPr id="12" name="demo-rule">
             <a:extLst xmlns:a="http://schemas.openxmlformats.org/drawingml/2006/main">
               <a:ext uri="{FF2B5EF4-FFF2-40B4-BE49-F238E27FC236}">
-                <a16:creationId xmlns:a16="http://schemas.microsoft.com/office/drawing/2014/main" id="{13BD980A-A00E-46D9-9CDB-01DFB0DC786E}"/>
+                <a16:creationId xmlns:a16="http://schemas.microsoft.com/office/drawing/2014/main" id="{E30763EB-3E3E-446D-92AD-22AF6B2E5E07}"/>
               </a:ext>
             </a:extLst>
           </p:cNvPr>
@@ -3095,7 +3095,7 @@
           <p:cNvPr id="13" name="demo-upload">
             <a:extLst xmlns:a="http://schemas.openxmlformats.org/drawingml/2006/main">
               <a:ext uri="{FF2B5EF4-FFF2-40B4-BE49-F238E27FC236}">
-                <a16:creationId xmlns:a16="http://schemas.microsoft.com/office/drawing/2014/main" id="{384BA603-D863-4C9E-B6BD-52BBD1BD110D}"/>
+                <a16:creationId xmlns:a16="http://schemas.microsoft.com/office/drawing/2014/main" id="{FD89099A-35B9-42CA-97B3-F7BE0825E15D}"/>
               </a:ext>
             </a:extLst>
           </p:cNvPr>
@@ -3162,7 +3162,7 @@
           <p:cNvPr id="14" name="demo-clinical">
             <a:extLst xmlns:a="http://schemas.openxmlformats.org/drawingml/2006/main">
               <a:ext uri="{FF2B5EF4-FFF2-40B4-BE49-F238E27FC236}">
-                <a16:creationId xmlns:a16="http://schemas.microsoft.com/office/drawing/2014/main" id="{73D4E48A-1C93-4015-BC07-08B66AF8F955}"/>
+                <a16:creationId xmlns:a16="http://schemas.microsoft.com/office/drawing/2014/main" id="{410CC04D-4C34-4E63-9C75-6D3908320C90}"/>
               </a:ext>
             </a:extLst>
           </p:cNvPr>
@@ -3210,7 +3210,7 @@
     </p:spTree>
     <p:extLst>
       <p:ext uri="{BB962C8B-B14F-4D97-AF65-F5344CB8AC3E}">
-        <p14:creationId xmlns:p14="http://schemas.microsoft.com/office/powerpoint/2010/main" val="100260962"/>
+        <p14:creationId xmlns:p14="http://schemas.microsoft.com/office/powerpoint/2010/main" val="1588673955"/>
       </p:ext>
     </p:extLst>
   </p:cSld>
@@ -3241,7 +3241,7 @@
           <p:cNvPr id="19" name="top-rule-11">
             <a:extLst xmlns:a="http://schemas.openxmlformats.org/drawingml/2006/main">
               <a:ext uri="{FF2B5EF4-FFF2-40B4-BE49-F238E27FC236}">
-                <a16:creationId xmlns:a16="http://schemas.microsoft.com/office/drawing/2014/main" id="{C97134D9-F372-4359-9242-3938D1B0C0EF}"/>
+                <a16:creationId xmlns:a16="http://schemas.microsoft.com/office/drawing/2014/main" id="{D540405B-79C7-4A92-818C-D542175B775C}"/>
               </a:ext>
             </a:extLst>
           </p:cNvPr>
@@ -3272,7 +3272,7 @@
           <p:cNvPr id="2" name="kicker-11">
             <a:extLst xmlns:a="http://schemas.openxmlformats.org/drawingml/2006/main">
               <a:ext uri="{FF2B5EF4-FFF2-40B4-BE49-F238E27FC236}">
-                <a16:creationId xmlns:a16="http://schemas.microsoft.com/office/drawing/2014/main" id="{1349242F-4A70-4C4B-8F90-9152873558D3}"/>
+                <a16:creationId xmlns:a16="http://schemas.microsoft.com/office/drawing/2014/main" id="{E3D8C545-A6D1-4512-A180-2CC16FEEF2A8}"/>
               </a:ext>
             </a:extLst>
           </p:cNvPr>
@@ -3322,7 +3322,7 @@
           <p:cNvPr id="3" name="slide-title-11">
             <a:extLst xmlns:a="http://schemas.openxmlformats.org/drawingml/2006/main">
               <a:ext uri="{FF2B5EF4-FFF2-40B4-BE49-F238E27FC236}">
-                <a16:creationId xmlns:a16="http://schemas.microsoft.com/office/drawing/2014/main" id="{6074CF46-F098-4478-8069-B5B50D7A18E1}"/>
+                <a16:creationId xmlns:a16="http://schemas.microsoft.com/office/drawing/2014/main" id="{ABC4ED0E-EE1A-4C9E-9568-FC41101CF57D}"/>
               </a:ext>
             </a:extLst>
           </p:cNvPr>
@@ -3372,7 +3372,7 @@
           <p:cNvPr id="4" name="footer-rule-11">
             <a:extLst xmlns:a="http://schemas.openxmlformats.org/drawingml/2006/main">
               <a:ext uri="{FF2B5EF4-FFF2-40B4-BE49-F238E27FC236}">
-                <a16:creationId xmlns:a16="http://schemas.microsoft.com/office/drawing/2014/main" id="{21ADD714-8D63-4D7E-B205-32E14D2C0FCE}"/>
+                <a16:creationId xmlns:a16="http://schemas.microsoft.com/office/drawing/2014/main" id="{2091ACDF-E233-480D-94FC-967748FEA6C4}"/>
               </a:ext>
             </a:extLst>
           </p:cNvPr>
@@ -3403,7 +3403,7 @@
           <p:cNvPr id="5" name="evidence-11">
             <a:extLst xmlns:a="http://schemas.openxmlformats.org/drawingml/2006/main">
               <a:ext uri="{FF2B5EF4-FFF2-40B4-BE49-F238E27FC236}">
-                <a16:creationId xmlns:a16="http://schemas.microsoft.com/office/drawing/2014/main" id="{F1EA70CA-4CC1-4EE2-B3BD-25F2C7AEFCAB}"/>
+                <a16:creationId xmlns:a16="http://schemas.microsoft.com/office/drawing/2014/main" id="{D041123B-474F-47FB-BE41-25444D6284D1}"/>
               </a:ext>
             </a:extLst>
           </p:cNvPr>
@@ -3453,7 +3453,7 @@
           <p:cNvPr id="6" name="page-11">
             <a:extLst xmlns:a="http://schemas.openxmlformats.org/drawingml/2006/main">
               <a:ext uri="{FF2B5EF4-FFF2-40B4-BE49-F238E27FC236}">
-                <a16:creationId xmlns:a16="http://schemas.microsoft.com/office/drawing/2014/main" id="{A5D911D5-3771-41F8-B6B8-9243368F0407}"/>
+                <a16:creationId xmlns:a16="http://schemas.microsoft.com/office/drawing/2014/main" id="{FCB89903-0F07-47C0-837A-8EE281B76B0C}"/>
               </a:ext>
             </a:extLst>
           </p:cNvPr>
@@ -3503,7 +3503,7 @@
           <p:cNvPr id="7" name="s11-reproducibility-claim-mark">
             <a:extLst xmlns:a="http://schemas.openxmlformats.org/drawingml/2006/main">
               <a:ext uri="{FF2B5EF4-FFF2-40B4-BE49-F238E27FC236}">
-                <a16:creationId xmlns:a16="http://schemas.microsoft.com/office/drawing/2014/main" id="{317148A9-11AC-4C64-A73D-8FF3A7DF6597}"/>
+                <a16:creationId xmlns:a16="http://schemas.microsoft.com/office/drawing/2014/main" id="{9A4CDADC-13D2-474A-A21C-DA2FEAD9BB95}"/>
               </a:ext>
             </a:extLst>
           </p:cNvPr>
@@ -3534,7 +3534,7 @@
           <p:cNvPr id="8" name="s11-reproducibility-claim">
             <a:extLst xmlns:a="http://schemas.openxmlformats.org/drawingml/2006/main">
               <a:ext uri="{FF2B5EF4-FFF2-40B4-BE49-F238E27FC236}">
-                <a16:creationId xmlns:a16="http://schemas.microsoft.com/office/drawing/2014/main" id="{131F632A-7A5D-4B54-BA90-3DA42E008521}"/>
+                <a16:creationId xmlns:a16="http://schemas.microsoft.com/office/drawing/2014/main" id="{9F85E532-3D43-49F4-8FC3-1C52E00BAC10}"/>
               </a:ext>
             </a:extLst>
           </p:cNvPr>
@@ -3584,7 +3584,7 @@
           <p:cNvPr id="9" name="repro-rule-0">
             <a:extLst xmlns:a="http://schemas.openxmlformats.org/drawingml/2006/main">
               <a:ext uri="{FF2B5EF4-FFF2-40B4-BE49-F238E27FC236}">
-                <a16:creationId xmlns:a16="http://schemas.microsoft.com/office/drawing/2014/main" id="{45399047-49EE-410F-82B1-039526D70F61}"/>
+                <a16:creationId xmlns:a16="http://schemas.microsoft.com/office/drawing/2014/main" id="{886FEAE4-74BF-4570-8FB0-962D22212FCA}"/>
               </a:ext>
             </a:extLst>
           </p:cNvPr>
@@ -3615,7 +3615,7 @@
           <p:cNvPr id="10" name="repro-title-0">
             <a:extLst xmlns:a="http://schemas.openxmlformats.org/drawingml/2006/main">
               <a:ext uri="{FF2B5EF4-FFF2-40B4-BE49-F238E27FC236}">
-                <a16:creationId xmlns:a16="http://schemas.microsoft.com/office/drawing/2014/main" id="{BBAA90AD-CB2E-4EEC-973E-628C2C3A8A77}"/>
+                <a16:creationId xmlns:a16="http://schemas.microsoft.com/office/drawing/2014/main" id="{980EE587-84C9-4AC0-B8D6-E46E0FBD9FB9}"/>
               </a:ext>
             </a:extLst>
           </p:cNvPr>
@@ -3665,7 +3665,7 @@
           <p:cNvPr id="11" name="repro-text-0">
             <a:extLst xmlns:a="http://schemas.openxmlformats.org/drawingml/2006/main">
               <a:ext uri="{FF2B5EF4-FFF2-40B4-BE49-F238E27FC236}">
-                <a16:creationId xmlns:a16="http://schemas.microsoft.com/office/drawing/2014/main" id="{7F4A0B0A-207A-4BF4-8DD8-DB3D48A28582}"/>
+                <a16:creationId xmlns:a16="http://schemas.microsoft.com/office/drawing/2014/main" id="{18B2CFE5-FD02-44BD-8C38-543AA921AB63}"/>
               </a:ext>
             </a:extLst>
           </p:cNvPr>
@@ -3783,7 +3783,7 @@
           <p:cNvPr id="12" name="repro-rule-1">
             <a:extLst xmlns:a="http://schemas.openxmlformats.org/drawingml/2006/main">
               <a:ext uri="{FF2B5EF4-FFF2-40B4-BE49-F238E27FC236}">
-                <a16:creationId xmlns:a16="http://schemas.microsoft.com/office/drawing/2014/main" id="{07647E36-5E3B-4BC5-B0DC-B002C1578BB0}"/>
+                <a16:creationId xmlns:a16="http://schemas.microsoft.com/office/drawing/2014/main" id="{8A734F24-1FE9-4B9B-8EB9-22BBE451FCC8}"/>
               </a:ext>
             </a:extLst>
           </p:cNvPr>
@@ -3814,7 +3814,7 @@
           <p:cNvPr id="13" name="repro-title-1">
             <a:extLst xmlns:a="http://schemas.openxmlformats.org/drawingml/2006/main">
               <a:ext uri="{FF2B5EF4-FFF2-40B4-BE49-F238E27FC236}">
-                <a16:creationId xmlns:a16="http://schemas.microsoft.com/office/drawing/2014/main" id="{BEAE3F00-2E66-4085-86CA-C9408C3F92BE}"/>
+                <a16:creationId xmlns:a16="http://schemas.microsoft.com/office/drawing/2014/main" id="{79B97AB9-A860-4FCC-8203-90BC58B84AE6}"/>
               </a:ext>
             </a:extLst>
           </p:cNvPr>
@@ -3864,7 +3864,7 @@
           <p:cNvPr id="14" name="repro-text-1">
             <a:extLst xmlns:a="http://schemas.openxmlformats.org/drawingml/2006/main">
               <a:ext uri="{FF2B5EF4-FFF2-40B4-BE49-F238E27FC236}">
-                <a16:creationId xmlns:a16="http://schemas.microsoft.com/office/drawing/2014/main" id="{633C6AB5-BAFD-4663-980E-D2479539E018}"/>
+                <a16:creationId xmlns:a16="http://schemas.microsoft.com/office/drawing/2014/main" id="{1BBACED4-55A2-45A5-84D5-29415720DE5D}"/>
               </a:ext>
             </a:extLst>
           </p:cNvPr>
@@ -3982,7 +3982,7 @@
           <p:cNvPr id="15" name="repro-rule-2">
             <a:extLst xmlns:a="http://schemas.openxmlformats.org/drawingml/2006/main">
               <a:ext uri="{FF2B5EF4-FFF2-40B4-BE49-F238E27FC236}">
-                <a16:creationId xmlns:a16="http://schemas.microsoft.com/office/drawing/2014/main" id="{F9770BF7-9CF8-4CD1-AA34-577ADB39C047}"/>
+                <a16:creationId xmlns:a16="http://schemas.microsoft.com/office/drawing/2014/main" id="{4E50E241-66EE-402D-B56E-AD844CC56B0C}"/>
               </a:ext>
             </a:extLst>
           </p:cNvPr>
@@ -4013,7 +4013,7 @@
           <p:cNvPr id="16" name="repro-title-2">
             <a:extLst xmlns:a="http://schemas.openxmlformats.org/drawingml/2006/main">
               <a:ext uri="{FF2B5EF4-FFF2-40B4-BE49-F238E27FC236}">
-                <a16:creationId xmlns:a16="http://schemas.microsoft.com/office/drawing/2014/main" id="{043573C1-3B62-4E34-963B-40AC03E43830}"/>
+                <a16:creationId xmlns:a16="http://schemas.microsoft.com/office/drawing/2014/main" id="{73901931-4F53-4A65-B643-1F2FD01D4394}"/>
               </a:ext>
             </a:extLst>
           </p:cNvPr>
@@ -4063,7 +4063,7 @@
           <p:cNvPr id="17" name="repro-text-2">
             <a:extLst xmlns:a="http://schemas.openxmlformats.org/drawingml/2006/main">
               <a:ext uri="{FF2B5EF4-FFF2-40B4-BE49-F238E27FC236}">
-                <a16:creationId xmlns:a16="http://schemas.microsoft.com/office/drawing/2014/main" id="{8AA4074C-8976-48E0-93DA-5D7AB23E0F89}"/>
+                <a16:creationId xmlns:a16="http://schemas.microsoft.com/office/drawing/2014/main" id="{329DF69B-22AB-469C-BC79-2E6ACA7B9B1F}"/>
               </a:ext>
             </a:extLst>
           </p:cNvPr>
@@ -4164,7 +4164,7 @@
           <p:cNvPr id="18" name="repro-protected">
             <a:extLst xmlns:a="http://schemas.openxmlformats.org/drawingml/2006/main">
               <a:ext uri="{FF2B5EF4-FFF2-40B4-BE49-F238E27FC236}">
-                <a16:creationId xmlns:a16="http://schemas.microsoft.com/office/drawing/2014/main" id="{B96FD88A-6AC4-4B30-90E2-640901D86D35}"/>
+                <a16:creationId xmlns:a16="http://schemas.microsoft.com/office/drawing/2014/main" id="{A7FC59AD-57FE-42CD-94A9-FB4E4DAF124B}"/>
               </a:ext>
             </a:extLst>
           </p:cNvPr>
@@ -4212,7 +4212,7 @@
     </p:spTree>
     <p:extLst>
       <p:ext uri="{BB962C8B-B14F-4D97-AF65-F5344CB8AC3E}">
-        <p14:creationId xmlns:p14="http://schemas.microsoft.com/office/powerpoint/2010/main" val="1550123791"/>
+        <p14:creationId xmlns:p14="http://schemas.microsoft.com/office/powerpoint/2010/main" val="226592456"/>
       </p:ext>
     </p:extLst>
   </p:cSld>
@@ -4243,7 +4243,7 @@
           <p:cNvPr id="18" name="top-rule-12">
             <a:extLst xmlns:a="http://schemas.openxmlformats.org/drawingml/2006/main">
               <a:ext uri="{FF2B5EF4-FFF2-40B4-BE49-F238E27FC236}">
-                <a16:creationId xmlns:a16="http://schemas.microsoft.com/office/drawing/2014/main" id="{C4F2CC0A-597D-459F-9922-07AB9BA508FD}"/>
+                <a16:creationId xmlns:a16="http://schemas.microsoft.com/office/drawing/2014/main" id="{665493BA-8A94-45B4-A459-FA35C351A90C}"/>
               </a:ext>
             </a:extLst>
           </p:cNvPr>
@@ -4274,7 +4274,7 @@
           <p:cNvPr id="2" name="kicker-12">
             <a:extLst xmlns:a="http://schemas.openxmlformats.org/drawingml/2006/main">
               <a:ext uri="{FF2B5EF4-FFF2-40B4-BE49-F238E27FC236}">
-                <a16:creationId xmlns:a16="http://schemas.microsoft.com/office/drawing/2014/main" id="{67B1B754-CD26-4FFF-B67C-C176F3BABB0E}"/>
+                <a16:creationId xmlns:a16="http://schemas.microsoft.com/office/drawing/2014/main" id="{69FD4F6B-E701-4C3E-BCED-164862EA0AE8}"/>
               </a:ext>
             </a:extLst>
           </p:cNvPr>
@@ -4324,7 +4324,7 @@
           <p:cNvPr id="3" name="slide-title-12">
             <a:extLst xmlns:a="http://schemas.openxmlformats.org/drawingml/2006/main">
               <a:ext uri="{FF2B5EF4-FFF2-40B4-BE49-F238E27FC236}">
-                <a16:creationId xmlns:a16="http://schemas.microsoft.com/office/drawing/2014/main" id="{827EF493-B915-4246-BA36-9D6B142EB5D0}"/>
+                <a16:creationId xmlns:a16="http://schemas.microsoft.com/office/drawing/2014/main" id="{0830B0BC-6C81-4A94-B2AE-C68D9A9F7235}"/>
               </a:ext>
             </a:extLst>
           </p:cNvPr>
@@ -4374,7 +4374,7 @@
           <p:cNvPr id="4" name="footer-rule-12">
             <a:extLst xmlns:a="http://schemas.openxmlformats.org/drawingml/2006/main">
               <a:ext uri="{FF2B5EF4-FFF2-40B4-BE49-F238E27FC236}">
-                <a16:creationId xmlns:a16="http://schemas.microsoft.com/office/drawing/2014/main" id="{C769D4AD-932E-4E00-9E7D-FECD155D2C1B}"/>
+                <a16:creationId xmlns:a16="http://schemas.microsoft.com/office/drawing/2014/main" id="{8D545446-465E-4410-97DD-1025D9458BA6}"/>
               </a:ext>
             </a:extLst>
           </p:cNvPr>
@@ -4405,7 +4405,7 @@
           <p:cNvPr id="5" name="evidence-12">
             <a:extLst xmlns:a="http://schemas.openxmlformats.org/drawingml/2006/main">
               <a:ext uri="{FF2B5EF4-FFF2-40B4-BE49-F238E27FC236}">
-                <a16:creationId xmlns:a16="http://schemas.microsoft.com/office/drawing/2014/main" id="{B0F6EF79-5BCC-42AE-81F7-E5368115729D}"/>
+                <a16:creationId xmlns:a16="http://schemas.microsoft.com/office/drawing/2014/main" id="{CE87AE42-3E9E-4572-B8C5-AF8C812905C8}"/>
               </a:ext>
             </a:extLst>
           </p:cNvPr>
@@ -4455,7 +4455,7 @@
           <p:cNvPr id="6" name="page-12">
             <a:extLst xmlns:a="http://schemas.openxmlformats.org/drawingml/2006/main">
               <a:ext uri="{FF2B5EF4-FFF2-40B4-BE49-F238E27FC236}">
-                <a16:creationId xmlns:a16="http://schemas.microsoft.com/office/drawing/2014/main" id="{5E10A3A9-813C-44BF-AF91-0EBE79A6F8A0}"/>
+                <a16:creationId xmlns:a16="http://schemas.microsoft.com/office/drawing/2014/main" id="{B401C0F8-8982-4B19-ABDB-273E2F646E8A}"/>
               </a:ext>
             </a:extLst>
           </p:cNvPr>
@@ -4505,7 +4505,7 @@
           <p:cNvPr id="7" name="s12-conclusion-claim-mark">
             <a:extLst xmlns:a="http://schemas.openxmlformats.org/drawingml/2006/main">
               <a:ext uri="{FF2B5EF4-FFF2-40B4-BE49-F238E27FC236}">
-                <a16:creationId xmlns:a16="http://schemas.microsoft.com/office/drawing/2014/main" id="{04D22FED-1D31-4270-903F-00F0141ADC74}"/>
+                <a16:creationId xmlns:a16="http://schemas.microsoft.com/office/drawing/2014/main" id="{7BC69F49-4431-4AD2-8820-9BD52A24EB4E}"/>
               </a:ext>
             </a:extLst>
           </p:cNvPr>
@@ -4536,7 +4536,7 @@
           <p:cNvPr id="8" name="s12-conclusion-claim">
             <a:extLst xmlns:a="http://schemas.openxmlformats.org/drawingml/2006/main">
               <a:ext uri="{FF2B5EF4-FFF2-40B4-BE49-F238E27FC236}">
-                <a16:creationId xmlns:a16="http://schemas.microsoft.com/office/drawing/2014/main" id="{6A7CE9A2-6145-40BA-87A8-B4DB0DD4274F}"/>
+                <a16:creationId xmlns:a16="http://schemas.microsoft.com/office/drawing/2014/main" id="{8EBFF402-64B0-4182-A533-114AC25DEC78}"/>
               </a:ext>
             </a:extLst>
           </p:cNvPr>
@@ -4586,7 +4586,7 @@
           <p:cNvPr id="9" name="conclusion-number-0">
             <a:extLst xmlns:a="http://schemas.openxmlformats.org/drawingml/2006/main">
               <a:ext uri="{FF2B5EF4-FFF2-40B4-BE49-F238E27FC236}">
-                <a16:creationId xmlns:a16="http://schemas.microsoft.com/office/drawing/2014/main" id="{D884B08C-9AEC-46E9-978A-9702F8B71F3D}"/>
+                <a16:creationId xmlns:a16="http://schemas.microsoft.com/office/drawing/2014/main" id="{AE02B78A-3041-491D-86AE-1F2092B98313}"/>
               </a:ext>
             </a:extLst>
           </p:cNvPr>
@@ -4636,7 +4636,7 @@
           <p:cNvPr id="10" name="conclusion-statement-0">
             <a:extLst xmlns:a="http://schemas.openxmlformats.org/drawingml/2006/main">
               <a:ext uri="{FF2B5EF4-FFF2-40B4-BE49-F238E27FC236}">
-                <a16:creationId xmlns:a16="http://schemas.microsoft.com/office/drawing/2014/main" id="{5EE8EAFD-43BA-4651-8B35-A81AFD2B78DF}"/>
+                <a16:creationId xmlns:a16="http://schemas.microsoft.com/office/drawing/2014/main" id="{4B36E912-DC78-4FD8-8432-5A902D54360E}"/>
               </a:ext>
             </a:extLst>
           </p:cNvPr>
@@ -4686,7 +4686,7 @@
           <p:cNvPr id="11" name="conclusion-number-1">
             <a:extLst xmlns:a="http://schemas.openxmlformats.org/drawingml/2006/main">
               <a:ext uri="{FF2B5EF4-FFF2-40B4-BE49-F238E27FC236}">
-                <a16:creationId xmlns:a16="http://schemas.microsoft.com/office/drawing/2014/main" id="{986001FE-7D03-4751-907C-A56F2D1BC89D}"/>
+                <a16:creationId xmlns:a16="http://schemas.microsoft.com/office/drawing/2014/main" id="{D376AD10-5D91-4672-82C6-CC0CEA56AD35}"/>
               </a:ext>
             </a:extLst>
           </p:cNvPr>
@@ -4736,7 +4736,7 @@
           <p:cNvPr id="12" name="conclusion-statement-1">
             <a:extLst xmlns:a="http://schemas.openxmlformats.org/drawingml/2006/main">
               <a:ext uri="{FF2B5EF4-FFF2-40B4-BE49-F238E27FC236}">
-                <a16:creationId xmlns:a16="http://schemas.microsoft.com/office/drawing/2014/main" id="{07BDEA9D-7F90-407F-BD8E-D45251233562}"/>
+                <a16:creationId xmlns:a16="http://schemas.microsoft.com/office/drawing/2014/main" id="{4773F329-2544-472B-B0EA-98D0333B4D40}"/>
               </a:ext>
             </a:extLst>
           </p:cNvPr>
@@ -4786,7 +4786,7 @@
           <p:cNvPr id="13" name="conclusion-number-2">
             <a:extLst xmlns:a="http://schemas.openxmlformats.org/drawingml/2006/main">
               <a:ext uri="{FF2B5EF4-FFF2-40B4-BE49-F238E27FC236}">
-                <a16:creationId xmlns:a16="http://schemas.microsoft.com/office/drawing/2014/main" id="{2EA5DD2B-51E5-4591-82A5-D69B498F066D}"/>
+                <a16:creationId xmlns:a16="http://schemas.microsoft.com/office/drawing/2014/main" id="{45ECD0DB-670A-46A6-B6D5-AB7DE23DC1E5}"/>
               </a:ext>
             </a:extLst>
           </p:cNvPr>
@@ -4836,7 +4836,7 @@
           <p:cNvPr id="14" name="conclusion-statement-2">
             <a:extLst xmlns:a="http://schemas.openxmlformats.org/drawingml/2006/main">
               <a:ext uri="{FF2B5EF4-FFF2-40B4-BE49-F238E27FC236}">
-                <a16:creationId xmlns:a16="http://schemas.microsoft.com/office/drawing/2014/main" id="{921DAEC9-4E60-4CDC-B82B-6F5B2BEEABE7}"/>
+                <a16:creationId xmlns:a16="http://schemas.microsoft.com/office/drawing/2014/main" id="{A8BB4D71-A169-411F-A310-9778A219A15F}"/>
               </a:ext>
             </a:extLst>
           </p:cNvPr>
@@ -4886,7 +4886,7 @@
           <p:cNvPr id="15" name="conclusion-next">
             <a:extLst xmlns:a="http://schemas.openxmlformats.org/drawingml/2006/main">
               <a:ext uri="{FF2B5EF4-FFF2-40B4-BE49-F238E27FC236}">
-                <a16:creationId xmlns:a16="http://schemas.microsoft.com/office/drawing/2014/main" id="{54B6A728-8743-4DF4-8D7E-09BF58285741}"/>
+                <a16:creationId xmlns:a16="http://schemas.microsoft.com/office/drawing/2014/main" id="{35AC30CB-46F2-498C-8393-FF8128976507}"/>
               </a:ext>
             </a:extLst>
           </p:cNvPr>
@@ -4917,7 +4917,7 @@
           <p:cNvPr id="16" name="conclusion-next-label">
             <a:extLst xmlns:a="http://schemas.openxmlformats.org/drawingml/2006/main">
               <a:ext uri="{FF2B5EF4-FFF2-40B4-BE49-F238E27FC236}">
-                <a16:creationId xmlns:a16="http://schemas.microsoft.com/office/drawing/2014/main" id="{F2FDF8DA-12E3-4AB3-8A43-09CCC958C44F}"/>
+                <a16:creationId xmlns:a16="http://schemas.microsoft.com/office/drawing/2014/main" id="{4262CBAE-81FE-468C-864A-17A1C1F03742}"/>
               </a:ext>
             </a:extLst>
           </p:cNvPr>
@@ -4967,7 +4967,7 @@
           <p:cNvPr id="17" name="conclusion-next-text">
             <a:extLst xmlns:a="http://schemas.openxmlformats.org/drawingml/2006/main">
               <a:ext uri="{FF2B5EF4-FFF2-40B4-BE49-F238E27FC236}">
-                <a16:creationId xmlns:a16="http://schemas.microsoft.com/office/drawing/2014/main" id="{C00E2EFE-0276-4AEF-B6BF-B7433F12A685}"/>
+                <a16:creationId xmlns:a16="http://schemas.microsoft.com/office/drawing/2014/main" id="{BE42A333-E3D1-466B-B887-4F193FEB169D}"/>
               </a:ext>
             </a:extLst>
           </p:cNvPr>
@@ -5015,7 +5015,7 @@
     </p:spTree>
     <p:extLst>
       <p:ext uri="{BB962C8B-B14F-4D97-AF65-F5344CB8AC3E}">
-        <p14:creationId xmlns:p14="http://schemas.microsoft.com/office/powerpoint/2010/main" val="362350487"/>
+        <p14:creationId xmlns:p14="http://schemas.microsoft.com/office/powerpoint/2010/main" val="1254663219"/>
       </p:ext>
     </p:extLst>
   </p:cSld>
@@ -5046,7 +5046,7 @@
           <p:cNvPr id="23" name="top-rule-2">
             <a:extLst xmlns:a="http://schemas.openxmlformats.org/drawingml/2006/main">
               <a:ext uri="{FF2B5EF4-FFF2-40B4-BE49-F238E27FC236}">
-                <a16:creationId xmlns:a16="http://schemas.microsoft.com/office/drawing/2014/main" id="{E16F9AE5-2539-468C-B3D7-C624855C8157}"/>
+                <a16:creationId xmlns:a16="http://schemas.microsoft.com/office/drawing/2014/main" id="{84306BE8-0FD6-4D52-9E94-990B8963780C}"/>
               </a:ext>
             </a:extLst>
           </p:cNvPr>
@@ -5077,7 +5077,7 @@
           <p:cNvPr id="2" name="kicker-2">
             <a:extLst xmlns:a="http://schemas.openxmlformats.org/drawingml/2006/main">
               <a:ext uri="{FF2B5EF4-FFF2-40B4-BE49-F238E27FC236}">
-                <a16:creationId xmlns:a16="http://schemas.microsoft.com/office/drawing/2014/main" id="{1DDBE280-00A4-4FE9-B88F-5F22BC99F7B4}"/>
+                <a16:creationId xmlns:a16="http://schemas.microsoft.com/office/drawing/2014/main" id="{BD0E5B06-04A8-4F83-9BDE-07D4774DFF47}"/>
               </a:ext>
             </a:extLst>
           </p:cNvPr>
@@ -5127,7 +5127,7 @@
           <p:cNvPr id="3" name="slide-title-2">
             <a:extLst xmlns:a="http://schemas.openxmlformats.org/drawingml/2006/main">
               <a:ext uri="{FF2B5EF4-FFF2-40B4-BE49-F238E27FC236}">
-                <a16:creationId xmlns:a16="http://schemas.microsoft.com/office/drawing/2014/main" id="{5BC77213-A734-477D-AE1E-EE0AE7E17C52}"/>
+                <a16:creationId xmlns:a16="http://schemas.microsoft.com/office/drawing/2014/main" id="{CE43D960-063B-4079-BAF7-B2F1EE7CDBF7}"/>
               </a:ext>
             </a:extLst>
           </p:cNvPr>
@@ -5177,7 +5177,7 @@
           <p:cNvPr id="4" name="footer-rule-2">
             <a:extLst xmlns:a="http://schemas.openxmlformats.org/drawingml/2006/main">
               <a:ext uri="{FF2B5EF4-FFF2-40B4-BE49-F238E27FC236}">
-                <a16:creationId xmlns:a16="http://schemas.microsoft.com/office/drawing/2014/main" id="{6854CDB9-CBC6-42CA-953C-B0184D80398F}"/>
+                <a16:creationId xmlns:a16="http://schemas.microsoft.com/office/drawing/2014/main" id="{49CB1ABD-902F-4167-A6E6-9121C8138E86}"/>
               </a:ext>
             </a:extLst>
           </p:cNvPr>
@@ -5208,7 +5208,7 @@
           <p:cNvPr id="5" name="evidence-2">
             <a:extLst xmlns:a="http://schemas.openxmlformats.org/drawingml/2006/main">
               <a:ext uri="{FF2B5EF4-FFF2-40B4-BE49-F238E27FC236}">
-                <a16:creationId xmlns:a16="http://schemas.microsoft.com/office/drawing/2014/main" id="{64127443-49B2-495F-9BC4-E934B3896DEA}"/>
+                <a16:creationId xmlns:a16="http://schemas.microsoft.com/office/drawing/2014/main" id="{4C780A20-271E-4932-8FB9-100319CEE630}"/>
               </a:ext>
             </a:extLst>
           </p:cNvPr>
@@ -5258,7 +5258,7 @@
           <p:cNvPr id="6" name="page-2">
             <a:extLst xmlns:a="http://schemas.openxmlformats.org/drawingml/2006/main">
               <a:ext uri="{FF2B5EF4-FFF2-40B4-BE49-F238E27FC236}">
-                <a16:creationId xmlns:a16="http://schemas.microsoft.com/office/drawing/2014/main" id="{60DA5E00-1A34-4DA5-BEC4-3DDC823EDBDF}"/>
+                <a16:creationId xmlns:a16="http://schemas.microsoft.com/office/drawing/2014/main" id="{C2105C0B-F86B-414A-80C5-31F720ABEF65}"/>
               </a:ext>
             </a:extLst>
           </p:cNvPr>
@@ -5308,7 +5308,7 @@
           <p:cNvPr id="7" name="s02-leakage-claim-mark">
             <a:extLst xmlns:a="http://schemas.openxmlformats.org/drawingml/2006/main">
               <a:ext uri="{FF2B5EF4-FFF2-40B4-BE49-F238E27FC236}">
-                <a16:creationId xmlns:a16="http://schemas.microsoft.com/office/drawing/2014/main" id="{1D39D8C7-61FF-4246-902F-0FDB722F0403}"/>
+                <a16:creationId xmlns:a16="http://schemas.microsoft.com/office/drawing/2014/main" id="{7C95709F-C92B-4F3F-A0BA-05A08569BD4F}"/>
               </a:ext>
             </a:extLst>
           </p:cNvPr>
@@ -5339,7 +5339,7 @@
           <p:cNvPr id="8" name="s02-leakage-claim">
             <a:extLst xmlns:a="http://schemas.openxmlformats.org/drawingml/2006/main">
               <a:ext uri="{FF2B5EF4-FFF2-40B4-BE49-F238E27FC236}">
-                <a16:creationId xmlns:a16="http://schemas.microsoft.com/office/drawing/2014/main" id="{EB33DAF9-1B35-440F-BAE8-9615ABECAB07}"/>
+                <a16:creationId xmlns:a16="http://schemas.microsoft.com/office/drawing/2014/main" id="{39907D71-DD96-407F-A748-09030D99A914}"/>
               </a:ext>
             </a:extLst>
           </p:cNvPr>
@@ -5389,7 +5389,7 @@
           <p:cNvPr id="9" name="leakage-boundary">
             <a:extLst xmlns:a="http://schemas.openxmlformats.org/drawingml/2006/main">
               <a:ext uri="{FF2B5EF4-FFF2-40B4-BE49-F238E27FC236}">
-                <a16:creationId xmlns:a16="http://schemas.microsoft.com/office/drawing/2014/main" id="{06E99B0C-AD4C-4204-9CE5-C405517A5C2B}"/>
+                <a16:creationId xmlns:a16="http://schemas.microsoft.com/office/drawing/2014/main" id="{FAF49E38-24F8-4E8F-A67F-AD74659A17BD}"/>
               </a:ext>
             </a:extLst>
           </p:cNvPr>
@@ -5420,7 +5420,7 @@
           <p:cNvPr id="10" name="leakage-cross-1">
             <a:extLst xmlns:a="http://schemas.openxmlformats.org/drawingml/2006/main">
               <a:ext uri="{FF2B5EF4-FFF2-40B4-BE49-F238E27FC236}">
-                <a16:creationId xmlns:a16="http://schemas.microsoft.com/office/drawing/2014/main" id="{237F44F6-0645-4C9A-9361-017983F004FF}"/>
+                <a16:creationId xmlns:a16="http://schemas.microsoft.com/office/drawing/2014/main" id="{68D32743-A066-414E-94E5-9F88EFBE1440}"/>
               </a:ext>
             </a:extLst>
           </p:cNvPr>
@@ -5451,7 +5451,7 @@
           <p:cNvPr id="11" name="leakage-cross-2">
             <a:extLst xmlns:a="http://schemas.openxmlformats.org/drawingml/2006/main">
               <a:ext uri="{FF2B5EF4-FFF2-40B4-BE49-F238E27FC236}">
-                <a16:creationId xmlns:a16="http://schemas.microsoft.com/office/drawing/2014/main" id="{E446C080-05D8-408E-810E-8BD8E2A3AB54}"/>
+                <a16:creationId xmlns:a16="http://schemas.microsoft.com/office/drawing/2014/main" id="{3E0EA02C-E09E-45F9-836C-38032B6DB7F1}"/>
               </a:ext>
             </a:extLst>
           </p:cNvPr>
@@ -5482,7 +5482,7 @@
           <p:cNvPr id="12" name="leakage-cross-3">
             <a:extLst xmlns:a="http://schemas.openxmlformats.org/drawingml/2006/main">
               <a:ext uri="{FF2B5EF4-FFF2-40B4-BE49-F238E27FC236}">
-                <a16:creationId xmlns:a16="http://schemas.microsoft.com/office/drawing/2014/main" id="{8B2A3EB9-B05B-47CD-8A81-FB92AADE319B}"/>
+                <a16:creationId xmlns:a16="http://schemas.microsoft.com/office/drawing/2014/main" id="{5DB6698F-F257-4F9A-A257-72192C6D4FA7}"/>
               </a:ext>
             </a:extLst>
           </p:cNvPr>
@@ -5513,7 +5513,7 @@
           <p:cNvPr id="13" name="s02-leakage-crossing patient IDs-value">
             <a:extLst xmlns:a="http://schemas.openxmlformats.org/drawingml/2006/main">
               <a:ext uri="{FF2B5EF4-FFF2-40B4-BE49-F238E27FC236}">
-                <a16:creationId xmlns:a16="http://schemas.microsoft.com/office/drawing/2014/main" id="{892D3F56-2C47-421B-83FA-F0610AAA23A8}"/>
+                <a16:creationId xmlns:a16="http://schemas.microsoft.com/office/drawing/2014/main" id="{2C42D761-5FB6-4E79-96C7-1FAE537B5BB1}"/>
               </a:ext>
             </a:extLst>
           </p:cNvPr>
@@ -5563,7 +5563,7 @@
           <p:cNvPr id="14" name="s02-leakage-crossing patient IDs-label">
             <a:extLst xmlns:a="http://schemas.openxmlformats.org/drawingml/2006/main">
               <a:ext uri="{FF2B5EF4-FFF2-40B4-BE49-F238E27FC236}">
-                <a16:creationId xmlns:a16="http://schemas.microsoft.com/office/drawing/2014/main" id="{581C78FB-6149-4494-B189-594DCD31D938}"/>
+                <a16:creationId xmlns:a16="http://schemas.microsoft.com/office/drawing/2014/main" id="{044E5432-2984-47A3-B10C-4EE6079DDA6D}"/>
               </a:ext>
             </a:extLst>
           </p:cNvPr>
@@ -5613,7 +5613,7 @@
           <p:cNvPr id="15" name="s02-leakage-cross-boundary rows-value">
             <a:extLst xmlns:a="http://schemas.openxmlformats.org/drawingml/2006/main">
               <a:ext uri="{FF2B5EF4-FFF2-40B4-BE49-F238E27FC236}">
-                <a16:creationId xmlns:a16="http://schemas.microsoft.com/office/drawing/2014/main" id="{2E7A9922-2C9F-4A94-B958-6E995CFF16E1}"/>
+                <a16:creationId xmlns:a16="http://schemas.microsoft.com/office/drawing/2014/main" id="{71F77780-349A-4794-B500-B26B327B4578}"/>
               </a:ext>
             </a:extLst>
           </p:cNvPr>
@@ -5663,7 +5663,7 @@
           <p:cNvPr id="16" name="s02-leakage-cross-boundary rows-label">
             <a:extLst xmlns:a="http://schemas.openxmlformats.org/drawingml/2006/main">
               <a:ext uri="{FF2B5EF4-FFF2-40B4-BE49-F238E27FC236}">
-                <a16:creationId xmlns:a16="http://schemas.microsoft.com/office/drawing/2014/main" id="{33ADBF1E-B055-40D7-8DAE-23E1A516C914}"/>
+                <a16:creationId xmlns:a16="http://schemas.microsoft.com/office/drawing/2014/main" id="{B0595D45-D9BB-4477-B1FF-824E6AE04B09}"/>
               </a:ext>
             </a:extLst>
           </p:cNvPr>
@@ -5713,7 +5713,7 @@
           <p:cNvPr id="17" name="s02-leakage-bullet-0">
             <a:extLst xmlns:a="http://schemas.openxmlformats.org/drawingml/2006/main">
               <a:ext uri="{FF2B5EF4-FFF2-40B4-BE49-F238E27FC236}">
-                <a16:creationId xmlns:a16="http://schemas.microsoft.com/office/drawing/2014/main" id="{9A14A074-ABEC-4FFF-9266-07BD8CD8FF0F}"/>
+                <a16:creationId xmlns:a16="http://schemas.microsoft.com/office/drawing/2014/main" id="{6DB1967A-55BA-4BFE-9842-276B0B9BEBA5}"/>
               </a:ext>
             </a:extLst>
           </p:cNvPr>
@@ -5744,7 +5744,7 @@
           <p:cNvPr id="18" name="s02-leakage-body-0">
             <a:extLst xmlns:a="http://schemas.openxmlformats.org/drawingml/2006/main">
               <a:ext uri="{FF2B5EF4-FFF2-40B4-BE49-F238E27FC236}">
-                <a16:creationId xmlns:a16="http://schemas.microsoft.com/office/drawing/2014/main" id="{A5D7559D-4EB1-4A15-89EA-15219006388F}"/>
+                <a16:creationId xmlns:a16="http://schemas.microsoft.com/office/drawing/2014/main" id="{1E44EAE6-D645-436F-B2A5-F55C56265438}"/>
               </a:ext>
             </a:extLst>
           </p:cNvPr>
@@ -5794,7 +5794,7 @@
           <p:cNvPr id="19" name="s02-leakage-bullet-1">
             <a:extLst xmlns:a="http://schemas.openxmlformats.org/drawingml/2006/main">
               <a:ext uri="{FF2B5EF4-FFF2-40B4-BE49-F238E27FC236}">
-                <a16:creationId xmlns:a16="http://schemas.microsoft.com/office/drawing/2014/main" id="{83F973FE-1B4E-41EB-BF08-C58F575E9B08}"/>
+                <a16:creationId xmlns:a16="http://schemas.microsoft.com/office/drawing/2014/main" id="{A8CD78E5-EA2F-408C-9D45-89FF4502D4FC}"/>
               </a:ext>
             </a:extLst>
           </p:cNvPr>
@@ -5825,7 +5825,7 @@
           <p:cNvPr id="20" name="s02-leakage-body-1">
             <a:extLst xmlns:a="http://schemas.openxmlformats.org/drawingml/2006/main">
               <a:ext uri="{FF2B5EF4-FFF2-40B4-BE49-F238E27FC236}">
-                <a16:creationId xmlns:a16="http://schemas.microsoft.com/office/drawing/2014/main" id="{104F809B-FD46-4E47-8424-79D26637A358}"/>
+                <a16:creationId xmlns:a16="http://schemas.microsoft.com/office/drawing/2014/main" id="{4B7C128A-F24D-464D-B3DE-8F13B103F416}"/>
               </a:ext>
             </a:extLst>
           </p:cNvPr>
@@ -5875,7 +5875,7 @@
           <p:cNvPr id="21" name="s02-leakage-bullet-2">
             <a:extLst xmlns:a="http://schemas.openxmlformats.org/drawingml/2006/main">
               <a:ext uri="{FF2B5EF4-FFF2-40B4-BE49-F238E27FC236}">
-                <a16:creationId xmlns:a16="http://schemas.microsoft.com/office/drawing/2014/main" id="{C014134B-E04C-4B7D-B27F-94CC277BE2DB}"/>
+                <a16:creationId xmlns:a16="http://schemas.microsoft.com/office/drawing/2014/main" id="{A3609BF5-70C2-4B6C-A609-A890E679502D}"/>
               </a:ext>
             </a:extLst>
           </p:cNvPr>
@@ -5906,7 +5906,7 @@
           <p:cNvPr id="22" name="s02-leakage-body-2">
             <a:extLst xmlns:a="http://schemas.openxmlformats.org/drawingml/2006/main">
               <a:ext uri="{FF2B5EF4-FFF2-40B4-BE49-F238E27FC236}">
-                <a16:creationId xmlns:a16="http://schemas.microsoft.com/office/drawing/2014/main" id="{5E067B58-0786-497F-8586-459DB51DAC60}"/>
+                <a16:creationId xmlns:a16="http://schemas.microsoft.com/office/drawing/2014/main" id="{23BC7BE7-B271-4CF7-9D73-C637E93E73B1}"/>
               </a:ext>
             </a:extLst>
           </p:cNvPr>
@@ -5954,7 +5954,7 @@
     </p:spTree>
     <p:extLst>
       <p:ext uri="{BB962C8B-B14F-4D97-AF65-F5344CB8AC3E}">
-        <p14:creationId xmlns:p14="http://schemas.microsoft.com/office/powerpoint/2010/main" val="1759653079"/>
+        <p14:creationId xmlns:p14="http://schemas.microsoft.com/office/powerpoint/2010/main" val="241188002"/>
       </p:ext>
     </p:extLst>
   </p:cSld>
@@ -5985,7 +5985,7 @@
           <p:cNvPr id="16" name="top-rule-3">
             <a:extLst xmlns:a="http://schemas.openxmlformats.org/drawingml/2006/main">
               <a:ext uri="{FF2B5EF4-FFF2-40B4-BE49-F238E27FC236}">
-                <a16:creationId xmlns:a16="http://schemas.microsoft.com/office/drawing/2014/main" id="{BFC25A31-C5F6-4B54-B266-527595F64559}"/>
+                <a16:creationId xmlns:a16="http://schemas.microsoft.com/office/drawing/2014/main" id="{877D8357-FD71-44C9-9A5A-0FBAB320A9E7}"/>
               </a:ext>
             </a:extLst>
           </p:cNvPr>
@@ -6016,7 +6016,7 @@
           <p:cNvPr id="2" name="kicker-3">
             <a:extLst xmlns:a="http://schemas.openxmlformats.org/drawingml/2006/main">
               <a:ext uri="{FF2B5EF4-FFF2-40B4-BE49-F238E27FC236}">
-                <a16:creationId xmlns:a16="http://schemas.microsoft.com/office/drawing/2014/main" id="{C08DA803-FE85-4C97-A02B-EA707A52897A}"/>
+                <a16:creationId xmlns:a16="http://schemas.microsoft.com/office/drawing/2014/main" id="{2199DE97-8170-4A67-A566-6C48D5A74EB3}"/>
               </a:ext>
             </a:extLst>
           </p:cNvPr>
@@ -6066,7 +6066,7 @@
           <p:cNvPr id="3" name="slide-title-3">
             <a:extLst xmlns:a="http://schemas.openxmlformats.org/drawingml/2006/main">
               <a:ext uri="{FF2B5EF4-FFF2-40B4-BE49-F238E27FC236}">
-                <a16:creationId xmlns:a16="http://schemas.microsoft.com/office/drawing/2014/main" id="{51F8D20D-6374-41E1-A933-5306A7EB37CA}"/>
+                <a16:creationId xmlns:a16="http://schemas.microsoft.com/office/drawing/2014/main" id="{8E30C2BE-65EB-4E76-8D0C-2A4C69FCF76E}"/>
               </a:ext>
             </a:extLst>
           </p:cNvPr>
@@ -6116,7 +6116,7 @@
           <p:cNvPr id="4" name="footer-rule-3">
             <a:extLst xmlns:a="http://schemas.openxmlformats.org/drawingml/2006/main">
               <a:ext uri="{FF2B5EF4-FFF2-40B4-BE49-F238E27FC236}">
-                <a16:creationId xmlns:a16="http://schemas.microsoft.com/office/drawing/2014/main" id="{0C1FDF53-AF6A-445E-8786-983EED7171A8}"/>
+                <a16:creationId xmlns:a16="http://schemas.microsoft.com/office/drawing/2014/main" id="{A2196693-737B-4869-8C88-0281E1A197A2}"/>
               </a:ext>
             </a:extLst>
           </p:cNvPr>
@@ -6147,7 +6147,7 @@
           <p:cNvPr id="5" name="evidence-3">
             <a:extLst xmlns:a="http://schemas.openxmlformats.org/drawingml/2006/main">
               <a:ext uri="{FF2B5EF4-FFF2-40B4-BE49-F238E27FC236}">
-                <a16:creationId xmlns:a16="http://schemas.microsoft.com/office/drawing/2014/main" id="{AD519990-ED4B-4DC7-A700-CDE706171CA5}"/>
+                <a16:creationId xmlns:a16="http://schemas.microsoft.com/office/drawing/2014/main" id="{34C3DCCD-4D4E-4226-9686-74CCA8EE2CCE}"/>
               </a:ext>
             </a:extLst>
           </p:cNvPr>
@@ -6197,7 +6197,7 @@
           <p:cNvPr id="6" name="page-3">
             <a:extLst xmlns:a="http://schemas.openxmlformats.org/drawingml/2006/main">
               <a:ext uri="{FF2B5EF4-FFF2-40B4-BE49-F238E27FC236}">
-                <a16:creationId xmlns:a16="http://schemas.microsoft.com/office/drawing/2014/main" id="{FC2306DD-CBEF-4524-8894-D3F5EDDFE771}"/>
+                <a16:creationId xmlns:a16="http://schemas.microsoft.com/office/drawing/2014/main" id="{2AEB549A-D83E-443B-AE65-AB5F3831DEDF}"/>
               </a:ext>
             </a:extLst>
           </p:cNvPr>
@@ -6247,7 +6247,7 @@
           <p:cNvPr id="7" name="s03-questions-claim-mark">
             <a:extLst xmlns:a="http://schemas.openxmlformats.org/drawingml/2006/main">
               <a:ext uri="{FF2B5EF4-FFF2-40B4-BE49-F238E27FC236}">
-                <a16:creationId xmlns:a16="http://schemas.microsoft.com/office/drawing/2014/main" id="{2045A6EC-5153-465C-93E2-476D14637290}"/>
+                <a16:creationId xmlns:a16="http://schemas.microsoft.com/office/drawing/2014/main" id="{B62E3CE9-EE6E-4378-8DC1-006CC39FD3DB}"/>
               </a:ext>
             </a:extLst>
           </p:cNvPr>
@@ -6278,7 +6278,7 @@
           <p:cNvPr id="8" name="s03-questions-claim">
             <a:extLst xmlns:a="http://schemas.openxmlformats.org/drawingml/2006/main">
               <a:ext uri="{FF2B5EF4-FFF2-40B4-BE49-F238E27FC236}">
-                <a16:creationId xmlns:a16="http://schemas.microsoft.com/office/drawing/2014/main" id="{0F1DC671-A996-429B-96CE-BEBE243291F7}"/>
+                <a16:creationId xmlns:a16="http://schemas.microsoft.com/office/drawing/2014/main" id="{310DBD25-37E5-4A4E-B139-6557E7F650D2}"/>
               </a:ext>
             </a:extLst>
           </p:cNvPr>
@@ -6328,7 +6328,7 @@
           <p:cNvPr id="9" name="question-divider">
             <a:extLst xmlns:a="http://schemas.openxmlformats.org/drawingml/2006/main">
               <a:ext uri="{FF2B5EF4-FFF2-40B4-BE49-F238E27FC236}">
-                <a16:creationId xmlns:a16="http://schemas.microsoft.com/office/drawing/2014/main" id="{D6784B5E-D41D-484E-B794-61D01F5EF3DB}"/>
+                <a16:creationId xmlns:a16="http://schemas.microsoft.com/office/drawing/2014/main" id="{ED50DE34-A1C0-4DD3-8248-611D088B7CC9}"/>
               </a:ext>
             </a:extLst>
           </p:cNvPr>
@@ -6359,7 +6359,7 @@
           <p:cNvPr id="10" name="rq1-label">
             <a:extLst xmlns:a="http://schemas.openxmlformats.org/drawingml/2006/main">
               <a:ext uri="{FF2B5EF4-FFF2-40B4-BE49-F238E27FC236}">
-                <a16:creationId xmlns:a16="http://schemas.microsoft.com/office/drawing/2014/main" id="{394BEBCB-BC26-4C96-BD7F-DCAE44A48CE2}"/>
+                <a16:creationId xmlns:a16="http://schemas.microsoft.com/office/drawing/2014/main" id="{8DB967C6-4994-4403-B4C1-790048D2B85A}"/>
               </a:ext>
             </a:extLst>
           </p:cNvPr>
@@ -6409,7 +6409,7 @@
           <p:cNvPr id="11" name="rq1-question">
             <a:extLst xmlns:a="http://schemas.openxmlformats.org/drawingml/2006/main">
               <a:ext uri="{FF2B5EF4-FFF2-40B4-BE49-F238E27FC236}">
-                <a16:creationId xmlns:a16="http://schemas.microsoft.com/office/drawing/2014/main" id="{6F5CF932-BCFB-4A10-9231-3A149B3CC5BE}"/>
+                <a16:creationId xmlns:a16="http://schemas.microsoft.com/office/drawing/2014/main" id="{0A159E58-64E9-4DCC-8062-6D10F9692D79}"/>
               </a:ext>
             </a:extLst>
           </p:cNvPr>
@@ -6459,7 +6459,7 @@
           <p:cNvPr id="12" name="rq1-contract">
             <a:extLst xmlns:a="http://schemas.openxmlformats.org/drawingml/2006/main">
               <a:ext uri="{FF2B5EF4-FFF2-40B4-BE49-F238E27FC236}">
-                <a16:creationId xmlns:a16="http://schemas.microsoft.com/office/drawing/2014/main" id="{18480D93-C026-4726-A401-414DAAF04280}"/>
+                <a16:creationId xmlns:a16="http://schemas.microsoft.com/office/drawing/2014/main" id="{9821A375-BEA0-481C-AFFC-FE11A80EBEC4}"/>
               </a:ext>
             </a:extLst>
           </p:cNvPr>
@@ -6543,7 +6543,7 @@
           <p:cNvPr id="13" name="rq2-label">
             <a:extLst xmlns:a="http://schemas.openxmlformats.org/drawingml/2006/main">
               <a:ext uri="{FF2B5EF4-FFF2-40B4-BE49-F238E27FC236}">
-                <a16:creationId xmlns:a16="http://schemas.microsoft.com/office/drawing/2014/main" id="{EF86A507-9522-4518-8758-6191FAE177D3}"/>
+                <a16:creationId xmlns:a16="http://schemas.microsoft.com/office/drawing/2014/main" id="{FB6B7CF6-2B6F-4585-AE18-E5D3E2CF9F3A}"/>
               </a:ext>
             </a:extLst>
           </p:cNvPr>
@@ -6593,7 +6593,7 @@
           <p:cNvPr id="14" name="rq2-question">
             <a:extLst xmlns:a="http://schemas.openxmlformats.org/drawingml/2006/main">
               <a:ext uri="{FF2B5EF4-FFF2-40B4-BE49-F238E27FC236}">
-                <a16:creationId xmlns:a16="http://schemas.microsoft.com/office/drawing/2014/main" id="{166FDD76-3BDF-444D-840E-0A5BC8A366A5}"/>
+                <a16:creationId xmlns:a16="http://schemas.microsoft.com/office/drawing/2014/main" id="{4EE6F65E-5006-431D-BB12-EFEDB05A95B4}"/>
               </a:ext>
             </a:extLst>
           </p:cNvPr>
@@ -6643,7 +6643,7 @@
           <p:cNvPr id="15" name="rq2-contract">
             <a:extLst xmlns:a="http://schemas.openxmlformats.org/drawingml/2006/main">
               <a:ext uri="{FF2B5EF4-FFF2-40B4-BE49-F238E27FC236}">
-                <a16:creationId xmlns:a16="http://schemas.microsoft.com/office/drawing/2014/main" id="{393C3A1F-14FF-4F74-9CFB-918DEB50B7EE}"/>
+                <a16:creationId xmlns:a16="http://schemas.microsoft.com/office/drawing/2014/main" id="{4DF8CA76-AB64-4E8F-8CAC-108FA90EE334}"/>
               </a:ext>
             </a:extLst>
           </p:cNvPr>
@@ -6725,7 +6725,7 @@
     </p:spTree>
     <p:extLst>
       <p:ext uri="{BB962C8B-B14F-4D97-AF65-F5344CB8AC3E}">
-        <p14:creationId xmlns:p14="http://schemas.microsoft.com/office/powerpoint/2010/main" val="2125303678"/>
+        <p14:creationId xmlns:p14="http://schemas.microsoft.com/office/powerpoint/2010/main" val="326821066"/>
       </p:ext>
     </p:extLst>
   </p:cSld>
@@ -6756,7 +6756,7 @@
           <p:cNvPr id="33" name="top-rule-4">
             <a:extLst xmlns:a="http://schemas.openxmlformats.org/drawingml/2006/main">
               <a:ext uri="{FF2B5EF4-FFF2-40B4-BE49-F238E27FC236}">
-                <a16:creationId xmlns:a16="http://schemas.microsoft.com/office/drawing/2014/main" id="{88DBF75F-9EC7-4A18-8BEC-A53CD89CB664}"/>
+                <a16:creationId xmlns:a16="http://schemas.microsoft.com/office/drawing/2014/main" id="{F844924F-EB6C-49A2-BB42-0B86C87122ED}"/>
               </a:ext>
             </a:extLst>
           </p:cNvPr>
@@ -6787,7 +6787,7 @@
           <p:cNvPr id="2" name="kicker-4">
             <a:extLst xmlns:a="http://schemas.openxmlformats.org/drawingml/2006/main">
               <a:ext uri="{FF2B5EF4-FFF2-40B4-BE49-F238E27FC236}">
-                <a16:creationId xmlns:a16="http://schemas.microsoft.com/office/drawing/2014/main" id="{0AD44117-937D-424B-9BDE-14D957F855C4}"/>
+                <a16:creationId xmlns:a16="http://schemas.microsoft.com/office/drawing/2014/main" id="{6B09B7F6-FB51-4526-846B-95051BDB4744}"/>
               </a:ext>
             </a:extLst>
           </p:cNvPr>
@@ -6837,7 +6837,7 @@
           <p:cNvPr id="3" name="slide-title-4">
             <a:extLst xmlns:a="http://schemas.openxmlformats.org/drawingml/2006/main">
               <a:ext uri="{FF2B5EF4-FFF2-40B4-BE49-F238E27FC236}">
-                <a16:creationId xmlns:a16="http://schemas.microsoft.com/office/drawing/2014/main" id="{0B1C8543-0817-4008-B1D8-D447F0E24163}"/>
+                <a16:creationId xmlns:a16="http://schemas.microsoft.com/office/drawing/2014/main" id="{967774F5-A945-44E2-AAFD-521E34ADF37B}"/>
               </a:ext>
             </a:extLst>
           </p:cNvPr>
@@ -6887,7 +6887,7 @@
           <p:cNvPr id="4" name="footer-rule-4">
             <a:extLst xmlns:a="http://schemas.openxmlformats.org/drawingml/2006/main">
               <a:ext uri="{FF2B5EF4-FFF2-40B4-BE49-F238E27FC236}">
-                <a16:creationId xmlns:a16="http://schemas.microsoft.com/office/drawing/2014/main" id="{15A64DAE-B665-4D6C-AD17-040F633EF9E8}"/>
+                <a16:creationId xmlns:a16="http://schemas.microsoft.com/office/drawing/2014/main" id="{4227CC40-D51F-4646-AE99-F95F052F35A0}"/>
               </a:ext>
             </a:extLst>
           </p:cNvPr>
@@ -6918,7 +6918,7 @@
           <p:cNvPr id="5" name="evidence-4">
             <a:extLst xmlns:a="http://schemas.openxmlformats.org/drawingml/2006/main">
               <a:ext uri="{FF2B5EF4-FFF2-40B4-BE49-F238E27FC236}">
-                <a16:creationId xmlns:a16="http://schemas.microsoft.com/office/drawing/2014/main" id="{C0041B60-F2DD-4156-8A70-8A0AB2A02258}"/>
+                <a16:creationId xmlns:a16="http://schemas.microsoft.com/office/drawing/2014/main" id="{6E5EA464-1CAF-4F22-B1B3-11210F6FE9E8}"/>
               </a:ext>
             </a:extLst>
           </p:cNvPr>
@@ -6968,7 +6968,7 @@
           <p:cNvPr id="6" name="page-4">
             <a:extLst xmlns:a="http://schemas.openxmlformats.org/drawingml/2006/main">
               <a:ext uri="{FF2B5EF4-FFF2-40B4-BE49-F238E27FC236}">
-                <a16:creationId xmlns:a16="http://schemas.microsoft.com/office/drawing/2014/main" id="{6CB4D3BB-75F2-4D2D-AB63-1A26B2763022}"/>
+                <a16:creationId xmlns:a16="http://schemas.microsoft.com/office/drawing/2014/main" id="{EC363936-B736-4144-A2EE-23AEA7B87D26}"/>
               </a:ext>
             </a:extLst>
           </p:cNvPr>
@@ -7018,7 +7018,7 @@
           <p:cNvPr id="7" name="s04-pipeline-claim-mark">
             <a:extLst xmlns:a="http://schemas.openxmlformats.org/drawingml/2006/main">
               <a:ext uri="{FF2B5EF4-FFF2-40B4-BE49-F238E27FC236}">
-                <a16:creationId xmlns:a16="http://schemas.microsoft.com/office/drawing/2014/main" id="{5F34B324-CB9B-4E07-B683-F9DCB3DF04AA}"/>
+                <a16:creationId xmlns:a16="http://schemas.microsoft.com/office/drawing/2014/main" id="{F155BD79-0491-4EC7-AFE1-A21DB9C53C6F}"/>
               </a:ext>
             </a:extLst>
           </p:cNvPr>
@@ -7049,7 +7049,7 @@
           <p:cNvPr id="8" name="s04-pipeline-claim">
             <a:extLst xmlns:a="http://schemas.openxmlformats.org/drawingml/2006/main">
               <a:ext uri="{FF2B5EF4-FFF2-40B4-BE49-F238E27FC236}">
-                <a16:creationId xmlns:a16="http://schemas.microsoft.com/office/drawing/2014/main" id="{8F6D2116-D745-4D7B-A37D-AFABF1D7A066}"/>
+                <a16:creationId xmlns:a16="http://schemas.microsoft.com/office/drawing/2014/main" id="{D7EFBAC8-D5C2-4B30-BA15-1E9E625B3072}"/>
               </a:ext>
             </a:extLst>
           </p:cNvPr>
@@ -7099,7 +7099,7 @@
           <p:cNvPr id="9" name="pipeline-edge-0">
             <a:extLst xmlns:a="http://schemas.openxmlformats.org/drawingml/2006/main">
               <a:ext uri="{FF2B5EF4-FFF2-40B4-BE49-F238E27FC236}">
-                <a16:creationId xmlns:a16="http://schemas.microsoft.com/office/drawing/2014/main" id="{A92FD8D3-9C56-4642-BFCC-ED35E254DA31}"/>
+                <a16:creationId xmlns:a16="http://schemas.microsoft.com/office/drawing/2014/main" id="{3C4E5506-DAB0-42B9-BB27-7E68873285F8}"/>
               </a:ext>
             </a:extLst>
           </p:cNvPr>
@@ -7130,7 +7130,7 @@
           <p:cNvPr id="10" name="pipeline-edge-1">
             <a:extLst xmlns:a="http://schemas.openxmlformats.org/drawingml/2006/main">
               <a:ext uri="{FF2B5EF4-FFF2-40B4-BE49-F238E27FC236}">
-                <a16:creationId xmlns:a16="http://schemas.microsoft.com/office/drawing/2014/main" id="{0954AA08-9474-427A-AAC6-1E8934DCBB26}"/>
+                <a16:creationId xmlns:a16="http://schemas.microsoft.com/office/drawing/2014/main" id="{E564C244-EF7D-4DF5-9B2B-97901B4691A8}"/>
               </a:ext>
             </a:extLst>
           </p:cNvPr>
@@ -7161,7 +7161,7 @@
           <p:cNvPr id="11" name="pipeline-edge-2">
             <a:extLst xmlns:a="http://schemas.openxmlformats.org/drawingml/2006/main">
               <a:ext uri="{FF2B5EF4-FFF2-40B4-BE49-F238E27FC236}">
-                <a16:creationId xmlns:a16="http://schemas.microsoft.com/office/drawing/2014/main" id="{A9F35EFF-E440-49F4-A612-4C91141022E2}"/>
+                <a16:creationId xmlns:a16="http://schemas.microsoft.com/office/drawing/2014/main" id="{F8B4A8A8-06DD-4DC2-B4A5-42AFD1F2EA8A}"/>
               </a:ext>
             </a:extLst>
           </p:cNvPr>
@@ -7192,7 +7192,7 @@
           <p:cNvPr id="12" name="pipeline-edge-3">
             <a:extLst xmlns:a="http://schemas.openxmlformats.org/drawingml/2006/main">
               <a:ext uri="{FF2B5EF4-FFF2-40B4-BE49-F238E27FC236}">
-                <a16:creationId xmlns:a16="http://schemas.microsoft.com/office/drawing/2014/main" id="{F267F745-7C55-40B0-A9C4-22A145ECF5F8}"/>
+                <a16:creationId xmlns:a16="http://schemas.microsoft.com/office/drawing/2014/main" id="{0C009200-AA49-4EAD-9B02-23E5AC4917B8}"/>
               </a:ext>
             </a:extLst>
           </p:cNvPr>
@@ -7223,7 +7223,7 @@
           <p:cNvPr id="13" name="pipeline-edge-4">
             <a:extLst xmlns:a="http://schemas.openxmlformats.org/drawingml/2006/main">
               <a:ext uri="{FF2B5EF4-FFF2-40B4-BE49-F238E27FC236}">
-                <a16:creationId xmlns:a16="http://schemas.microsoft.com/office/drawing/2014/main" id="{807D42CD-313F-49FF-B695-DCBCAC9DAB41}"/>
+                <a16:creationId xmlns:a16="http://schemas.microsoft.com/office/drawing/2014/main" id="{B2B16FDD-BDCB-44F4-9955-3938D04537F5}"/>
               </a:ext>
             </a:extLst>
           </p:cNvPr>
@@ -7254,7 +7254,7 @@
           <p:cNvPr id="14" name="pipeline-node-0">
             <a:extLst xmlns:a="http://schemas.openxmlformats.org/drawingml/2006/main">
               <a:ext uri="{FF2B5EF4-FFF2-40B4-BE49-F238E27FC236}">
-                <a16:creationId xmlns:a16="http://schemas.microsoft.com/office/drawing/2014/main" id="{21B53D76-5D2A-4585-8286-8B1DE031C9B5}"/>
+                <a16:creationId xmlns:a16="http://schemas.microsoft.com/office/drawing/2014/main" id="{21E2F864-EB32-4948-B5E1-8519E01791D4}"/>
               </a:ext>
             </a:extLst>
           </p:cNvPr>
@@ -7289,7 +7289,7 @@
           <p:cNvPr id="15" name="pipeline-number-0">
             <a:extLst xmlns:a="http://schemas.openxmlformats.org/drawingml/2006/main">
               <a:ext uri="{FF2B5EF4-FFF2-40B4-BE49-F238E27FC236}">
-                <a16:creationId xmlns:a16="http://schemas.microsoft.com/office/drawing/2014/main" id="{F5142106-D1AA-4D19-8B41-8B702F44F7FE}"/>
+                <a16:creationId xmlns:a16="http://schemas.microsoft.com/office/drawing/2014/main" id="{D64EDFBE-484A-4D91-9137-DD057101BE66}"/>
               </a:ext>
             </a:extLst>
           </p:cNvPr>
@@ -7339,7 +7339,7 @@
           <p:cNvPr id="16" name="pipeline-label-0">
             <a:extLst xmlns:a="http://schemas.openxmlformats.org/drawingml/2006/main">
               <a:ext uri="{FF2B5EF4-FFF2-40B4-BE49-F238E27FC236}">
-                <a16:creationId xmlns:a16="http://schemas.microsoft.com/office/drawing/2014/main" id="{91BE28E7-39B9-4FE4-AB4E-9D0F39E3E6AC}"/>
+                <a16:creationId xmlns:a16="http://schemas.microsoft.com/office/drawing/2014/main" id="{85B4E83F-C3BD-490D-9B86-B666AFE308CE}"/>
               </a:ext>
             </a:extLst>
           </p:cNvPr>
@@ -7389,7 +7389,7 @@
           <p:cNvPr id="17" name="pipeline-node-1">
             <a:extLst xmlns:a="http://schemas.openxmlformats.org/drawingml/2006/main">
               <a:ext uri="{FF2B5EF4-FFF2-40B4-BE49-F238E27FC236}">
-                <a16:creationId xmlns:a16="http://schemas.microsoft.com/office/drawing/2014/main" id="{F8FDF238-C2CA-4E4B-A208-96B1BF3F365E}"/>
+                <a16:creationId xmlns:a16="http://schemas.microsoft.com/office/drawing/2014/main" id="{6296BAD4-7F5B-46DA-BECD-DDFFCFA58A74}"/>
               </a:ext>
             </a:extLst>
           </p:cNvPr>
@@ -7424,7 +7424,7 @@
           <p:cNvPr id="18" name="pipeline-number-1">
             <a:extLst xmlns:a="http://schemas.openxmlformats.org/drawingml/2006/main">
               <a:ext uri="{FF2B5EF4-FFF2-40B4-BE49-F238E27FC236}">
-                <a16:creationId xmlns:a16="http://schemas.microsoft.com/office/drawing/2014/main" id="{871D5FAA-EDB8-4FB0-B9F2-C4B6E4C031AB}"/>
+                <a16:creationId xmlns:a16="http://schemas.microsoft.com/office/drawing/2014/main" id="{D2FD6908-C19D-40B8-BDB4-8C1557DD0BA6}"/>
               </a:ext>
             </a:extLst>
           </p:cNvPr>
@@ -7474,7 +7474,7 @@
           <p:cNvPr id="19" name="pipeline-label-1">
             <a:extLst xmlns:a="http://schemas.openxmlformats.org/drawingml/2006/main">
               <a:ext uri="{FF2B5EF4-FFF2-40B4-BE49-F238E27FC236}">
-                <a16:creationId xmlns:a16="http://schemas.microsoft.com/office/drawing/2014/main" id="{7678BB07-D125-43FF-B917-CB70AB1D33C7}"/>
+                <a16:creationId xmlns:a16="http://schemas.microsoft.com/office/drawing/2014/main" id="{2B105B99-09A5-45FC-B9A9-B5042434E91E}"/>
               </a:ext>
             </a:extLst>
           </p:cNvPr>
@@ -7524,7 +7524,7 @@
           <p:cNvPr id="20" name="pipeline-node-2">
             <a:extLst xmlns:a="http://schemas.openxmlformats.org/drawingml/2006/main">
               <a:ext uri="{FF2B5EF4-FFF2-40B4-BE49-F238E27FC236}">
-                <a16:creationId xmlns:a16="http://schemas.microsoft.com/office/drawing/2014/main" id="{7ABCBCCD-9649-4071-A9CC-7CCA26D88DD0}"/>
+                <a16:creationId xmlns:a16="http://schemas.microsoft.com/office/drawing/2014/main" id="{F6EBC112-83F0-4EE9-B102-989548DBFF28}"/>
               </a:ext>
             </a:extLst>
           </p:cNvPr>
@@ -7559,7 +7559,7 @@
           <p:cNvPr id="21" name="pipeline-number-2">
             <a:extLst xmlns:a="http://schemas.openxmlformats.org/drawingml/2006/main">
               <a:ext uri="{FF2B5EF4-FFF2-40B4-BE49-F238E27FC236}">
-                <a16:creationId xmlns:a16="http://schemas.microsoft.com/office/drawing/2014/main" id="{CB5DC307-1FB9-4D38-97BE-9607FFB26E61}"/>
+                <a16:creationId xmlns:a16="http://schemas.microsoft.com/office/drawing/2014/main" id="{7DD47A05-23B7-4622-B1EE-890E2F12BE7E}"/>
               </a:ext>
             </a:extLst>
           </p:cNvPr>
@@ -7609,7 +7609,7 @@
           <p:cNvPr id="22" name="pipeline-label-2">
             <a:extLst xmlns:a="http://schemas.openxmlformats.org/drawingml/2006/main">
               <a:ext uri="{FF2B5EF4-FFF2-40B4-BE49-F238E27FC236}">
-                <a16:creationId xmlns:a16="http://schemas.microsoft.com/office/drawing/2014/main" id="{41262886-58B2-4236-B117-399EA1FD1FE1}"/>
+                <a16:creationId xmlns:a16="http://schemas.microsoft.com/office/drawing/2014/main" id="{105BC9C4-966E-4E88-8CB1-28CF091AAC7C}"/>
               </a:ext>
             </a:extLst>
           </p:cNvPr>
@@ -7659,7 +7659,7 @@
           <p:cNvPr id="23" name="pipeline-node-3">
             <a:extLst xmlns:a="http://schemas.openxmlformats.org/drawingml/2006/main">
               <a:ext uri="{FF2B5EF4-FFF2-40B4-BE49-F238E27FC236}">
-                <a16:creationId xmlns:a16="http://schemas.microsoft.com/office/drawing/2014/main" id="{2FC00B18-6D24-4D1E-8B30-6DFF60F3024A}"/>
+                <a16:creationId xmlns:a16="http://schemas.microsoft.com/office/drawing/2014/main" id="{E743D5F7-CC54-44FF-8566-FB4CB17BFF0F}"/>
               </a:ext>
             </a:extLst>
           </p:cNvPr>
@@ -7694,7 +7694,7 @@
           <p:cNvPr id="24" name="pipeline-number-3">
             <a:extLst xmlns:a="http://schemas.openxmlformats.org/drawingml/2006/main">
               <a:ext uri="{FF2B5EF4-FFF2-40B4-BE49-F238E27FC236}">
-                <a16:creationId xmlns:a16="http://schemas.microsoft.com/office/drawing/2014/main" id="{9E162B3B-4099-4709-AA93-39D0E5E26812}"/>
+                <a16:creationId xmlns:a16="http://schemas.microsoft.com/office/drawing/2014/main" id="{4EA91954-87A7-4992-940D-97DF572804F6}"/>
               </a:ext>
             </a:extLst>
           </p:cNvPr>
@@ -7744,7 +7744,7 @@
           <p:cNvPr id="25" name="pipeline-label-3">
             <a:extLst xmlns:a="http://schemas.openxmlformats.org/drawingml/2006/main">
               <a:ext uri="{FF2B5EF4-FFF2-40B4-BE49-F238E27FC236}">
-                <a16:creationId xmlns:a16="http://schemas.microsoft.com/office/drawing/2014/main" id="{45D6ADB1-3B15-4C77-919C-11D5CECF35A0}"/>
+                <a16:creationId xmlns:a16="http://schemas.microsoft.com/office/drawing/2014/main" id="{1F68DA70-8931-4DA6-9955-4F38B840F36C}"/>
               </a:ext>
             </a:extLst>
           </p:cNvPr>
@@ -7794,7 +7794,7 @@
           <p:cNvPr id="26" name="pipeline-node-4">
             <a:extLst xmlns:a="http://schemas.openxmlformats.org/drawingml/2006/main">
               <a:ext uri="{FF2B5EF4-FFF2-40B4-BE49-F238E27FC236}">
-                <a16:creationId xmlns:a16="http://schemas.microsoft.com/office/drawing/2014/main" id="{F5D074A9-7016-4812-91C3-4629D96C8405}"/>
+                <a16:creationId xmlns:a16="http://schemas.microsoft.com/office/drawing/2014/main" id="{16C20DD3-B974-4821-AEFE-70FB424ACC7F}"/>
               </a:ext>
             </a:extLst>
           </p:cNvPr>
@@ -7829,7 +7829,7 @@
           <p:cNvPr id="27" name="pipeline-number-4">
             <a:extLst xmlns:a="http://schemas.openxmlformats.org/drawingml/2006/main">
               <a:ext uri="{FF2B5EF4-FFF2-40B4-BE49-F238E27FC236}">
-                <a16:creationId xmlns:a16="http://schemas.microsoft.com/office/drawing/2014/main" id="{EC32157A-12E5-4A51-858D-68772CEECE92}"/>
+                <a16:creationId xmlns:a16="http://schemas.microsoft.com/office/drawing/2014/main" id="{8FACA444-3446-4CE5-9B78-9ABD449C24FA}"/>
               </a:ext>
             </a:extLst>
           </p:cNvPr>
@@ -7879,7 +7879,7 @@
           <p:cNvPr id="28" name="pipeline-label-4">
             <a:extLst xmlns:a="http://schemas.openxmlformats.org/drawingml/2006/main">
               <a:ext uri="{FF2B5EF4-FFF2-40B4-BE49-F238E27FC236}">
-                <a16:creationId xmlns:a16="http://schemas.microsoft.com/office/drawing/2014/main" id="{C22586BC-F2CF-4AFA-89C8-567E95FBA2E6}"/>
+                <a16:creationId xmlns:a16="http://schemas.microsoft.com/office/drawing/2014/main" id="{F867076A-0D79-4934-9222-955E3B95CF7C}"/>
               </a:ext>
             </a:extLst>
           </p:cNvPr>
@@ -7929,7 +7929,7 @@
           <p:cNvPr id="29" name="pipeline-node-5">
             <a:extLst xmlns:a="http://schemas.openxmlformats.org/drawingml/2006/main">
               <a:ext uri="{FF2B5EF4-FFF2-40B4-BE49-F238E27FC236}">
-                <a16:creationId xmlns:a16="http://schemas.microsoft.com/office/drawing/2014/main" id="{20943A93-C7D5-40DB-95F3-F3A1628C43A8}"/>
+                <a16:creationId xmlns:a16="http://schemas.microsoft.com/office/drawing/2014/main" id="{17977BED-A192-4D4C-928C-4EEF7F72270A}"/>
               </a:ext>
             </a:extLst>
           </p:cNvPr>
@@ -7964,7 +7964,7 @@
           <p:cNvPr id="30" name="pipeline-number-5">
             <a:extLst xmlns:a="http://schemas.openxmlformats.org/drawingml/2006/main">
               <a:ext uri="{FF2B5EF4-FFF2-40B4-BE49-F238E27FC236}">
-                <a16:creationId xmlns:a16="http://schemas.microsoft.com/office/drawing/2014/main" id="{583EA34A-679E-4A9D-8B7F-3B1376AEC61D}"/>
+                <a16:creationId xmlns:a16="http://schemas.microsoft.com/office/drawing/2014/main" id="{39EEA75A-C645-4B45-BECF-05C0D36621C4}"/>
               </a:ext>
             </a:extLst>
           </p:cNvPr>
@@ -8014,7 +8014,7 @@
           <p:cNvPr id="31" name="pipeline-label-5">
             <a:extLst xmlns:a="http://schemas.openxmlformats.org/drawingml/2006/main">
               <a:ext uri="{FF2B5EF4-FFF2-40B4-BE49-F238E27FC236}">
-                <a16:creationId xmlns:a16="http://schemas.microsoft.com/office/drawing/2014/main" id="{A4780E57-9366-4A7E-9BFF-2A08C0195C13}"/>
+                <a16:creationId xmlns:a16="http://schemas.microsoft.com/office/drawing/2014/main" id="{D3ED6320-99E7-4086-8EA3-B610C3D86396}"/>
               </a:ext>
             </a:extLst>
           </p:cNvPr>
@@ -8064,7 +8064,7 @@
           <p:cNvPr id="32" name="pipeline-html-note">
             <a:extLst xmlns:a="http://schemas.openxmlformats.org/drawingml/2006/main">
               <a:ext uri="{FF2B5EF4-FFF2-40B4-BE49-F238E27FC236}">
-                <a16:creationId xmlns:a16="http://schemas.microsoft.com/office/drawing/2014/main" id="{5DC2630F-6A40-407B-A4C7-57B6A853E9B2}"/>
+                <a16:creationId xmlns:a16="http://schemas.microsoft.com/office/drawing/2014/main" id="{D100E363-5DFD-4E29-BBC5-AF06518673D6}"/>
               </a:ext>
             </a:extLst>
           </p:cNvPr>
@@ -8112,7 +8112,7 @@
     </p:spTree>
     <p:extLst>
       <p:ext uri="{BB962C8B-B14F-4D97-AF65-F5344CB8AC3E}">
-        <p14:creationId xmlns:p14="http://schemas.microsoft.com/office/powerpoint/2010/main" val="11174189"/>
+        <p14:creationId xmlns:p14="http://schemas.microsoft.com/office/powerpoint/2010/main" val="2101786815"/>
       </p:ext>
     </p:extLst>
   </p:cSld>
@@ -8143,7 +8143,7 @@
           <p:cNvPr id="19" name="top-rule-5">
             <a:extLst xmlns:a="http://schemas.openxmlformats.org/drawingml/2006/main">
               <a:ext uri="{FF2B5EF4-FFF2-40B4-BE49-F238E27FC236}">
-                <a16:creationId xmlns:a16="http://schemas.microsoft.com/office/drawing/2014/main" id="{7A47FA4E-C167-4D78-A972-6DF85D1FE1D7}"/>
+                <a16:creationId xmlns:a16="http://schemas.microsoft.com/office/drawing/2014/main" id="{2558A388-67A9-43AF-B348-9C9E39682245}"/>
               </a:ext>
             </a:extLst>
           </p:cNvPr>
@@ -8174,7 +8174,7 @@
           <p:cNvPr id="2" name="kicker-5">
             <a:extLst xmlns:a="http://schemas.openxmlformats.org/drawingml/2006/main">
               <a:ext uri="{FF2B5EF4-FFF2-40B4-BE49-F238E27FC236}">
-                <a16:creationId xmlns:a16="http://schemas.microsoft.com/office/drawing/2014/main" id="{11CE4ABC-9D45-431C-B618-E85031D4822E}"/>
+                <a16:creationId xmlns:a16="http://schemas.microsoft.com/office/drawing/2014/main" id="{0B5C2954-F87E-4817-A0F9-429F3D4981E0}"/>
               </a:ext>
             </a:extLst>
           </p:cNvPr>
@@ -8224,7 +8224,7 @@
           <p:cNvPr id="3" name="slide-title-5">
             <a:extLst xmlns:a="http://schemas.openxmlformats.org/drawingml/2006/main">
               <a:ext uri="{FF2B5EF4-FFF2-40B4-BE49-F238E27FC236}">
-                <a16:creationId xmlns:a16="http://schemas.microsoft.com/office/drawing/2014/main" id="{19290370-0D60-47BB-ACCA-FCD2017DF966}"/>
+                <a16:creationId xmlns:a16="http://schemas.microsoft.com/office/drawing/2014/main" id="{4EB06D9F-8A61-4566-A76A-B78FFF5D2686}"/>
               </a:ext>
             </a:extLst>
           </p:cNvPr>
@@ -8274,7 +8274,7 @@
           <p:cNvPr id="4" name="footer-rule-5">
             <a:extLst xmlns:a="http://schemas.openxmlformats.org/drawingml/2006/main">
               <a:ext uri="{FF2B5EF4-FFF2-40B4-BE49-F238E27FC236}">
-                <a16:creationId xmlns:a16="http://schemas.microsoft.com/office/drawing/2014/main" id="{F5EFDDB1-EC90-43ED-A7F3-B022C86E6DD2}"/>
+                <a16:creationId xmlns:a16="http://schemas.microsoft.com/office/drawing/2014/main" id="{DCCDF054-F1ED-4B58-90B4-2764D83B4A48}"/>
               </a:ext>
             </a:extLst>
           </p:cNvPr>
@@ -8305,7 +8305,7 @@
           <p:cNvPr id="5" name="evidence-5">
             <a:extLst xmlns:a="http://schemas.openxmlformats.org/drawingml/2006/main">
               <a:ext uri="{FF2B5EF4-FFF2-40B4-BE49-F238E27FC236}">
-                <a16:creationId xmlns:a16="http://schemas.microsoft.com/office/drawing/2014/main" id="{2402C6F5-13DA-4C38-AE64-7CFD77ED9620}"/>
+                <a16:creationId xmlns:a16="http://schemas.microsoft.com/office/drawing/2014/main" id="{EE2A296B-9B51-4F57-9361-2CE97F64AD54}"/>
               </a:ext>
             </a:extLst>
           </p:cNvPr>
@@ -8355,7 +8355,7 @@
           <p:cNvPr id="6" name="page-5">
             <a:extLst xmlns:a="http://schemas.openxmlformats.org/drawingml/2006/main">
               <a:ext uri="{FF2B5EF4-FFF2-40B4-BE49-F238E27FC236}">
-                <a16:creationId xmlns:a16="http://schemas.microsoft.com/office/drawing/2014/main" id="{6C9025A8-262C-49ED-A5A8-B8C06D0916CE}"/>
+                <a16:creationId xmlns:a16="http://schemas.microsoft.com/office/drawing/2014/main" id="{71D1DB12-E2B4-488A-B41E-F47BCED133D6}"/>
               </a:ext>
             </a:extLst>
           </p:cNvPr>
@@ -8405,7 +8405,7 @@
           <p:cNvPr id="7" name="s05-data-claim-mark">
             <a:extLst xmlns:a="http://schemas.openxmlformats.org/drawingml/2006/main">
               <a:ext uri="{FF2B5EF4-FFF2-40B4-BE49-F238E27FC236}">
-                <a16:creationId xmlns:a16="http://schemas.microsoft.com/office/drawing/2014/main" id="{1732CDE8-EA3B-44D2-9868-F3260C01C903}"/>
+                <a16:creationId xmlns:a16="http://schemas.microsoft.com/office/drawing/2014/main" id="{22395987-D2FE-4ED6-AC1C-EAEBDBAB385C}"/>
               </a:ext>
             </a:extLst>
           </p:cNvPr>
@@ -8436,7 +8436,7 @@
           <p:cNvPr id="8" name="s05-data-claim">
             <a:extLst xmlns:a="http://schemas.openxmlformats.org/drawingml/2006/main">
               <a:ext uri="{FF2B5EF4-FFF2-40B4-BE49-F238E27FC236}">
-                <a16:creationId xmlns:a16="http://schemas.microsoft.com/office/drawing/2014/main" id="{CB37EE21-6A9A-4B0D-B812-2363C3A6CC9C}"/>
+                <a16:creationId xmlns:a16="http://schemas.microsoft.com/office/drawing/2014/main" id="{5F0A980D-C8BF-46C5-9F9B-FAB1ADA63995}"/>
               </a:ext>
             </a:extLst>
           </p:cNvPr>
@@ -8486,7 +8486,7 @@
           <p:cNvPr id="9" name="data-total">
             <a:extLst xmlns:a="http://schemas.openxmlformats.org/drawingml/2006/main">
               <a:ext uri="{FF2B5EF4-FFF2-40B4-BE49-F238E27FC236}">
-                <a16:creationId xmlns:a16="http://schemas.microsoft.com/office/drawing/2014/main" id="{C7F9579B-3731-4831-B436-B0D78B9466AA}"/>
+                <a16:creationId xmlns:a16="http://schemas.microsoft.com/office/drawing/2014/main" id="{98687FCA-D424-4E90-84C7-68DCF1703773}"/>
               </a:ext>
             </a:extLst>
           </p:cNvPr>
@@ -8536,7 +8536,7 @@
           <p:cNvPr id="10" name="data-total-label">
             <a:extLst xmlns:a="http://schemas.openxmlformats.org/drawingml/2006/main">
               <a:ext uri="{FF2B5EF4-FFF2-40B4-BE49-F238E27FC236}">
-                <a16:creationId xmlns:a16="http://schemas.microsoft.com/office/drawing/2014/main" id="{AF176A43-94BB-4C99-B541-E298EBFE399D}"/>
+                <a16:creationId xmlns:a16="http://schemas.microsoft.com/office/drawing/2014/main" id="{46EA7BDA-E68E-4222-B1EB-2BFA1CC9195A}"/>
               </a:ext>
             </a:extLst>
           </p:cNvPr>
@@ -8586,7 +8586,7 @@
           <p:cNvPr id="11" name="data-train-bar">
             <a:extLst xmlns:a="http://schemas.openxmlformats.org/drawingml/2006/main">
               <a:ext uri="{FF2B5EF4-FFF2-40B4-BE49-F238E27FC236}">
-                <a16:creationId xmlns:a16="http://schemas.microsoft.com/office/drawing/2014/main" id="{35E5265D-5986-48C5-B3D5-EE0BB821553B}"/>
+                <a16:creationId xmlns:a16="http://schemas.microsoft.com/office/drawing/2014/main" id="{8925A8BD-5A46-465A-99E1-4F3EFC24B84A}"/>
               </a:ext>
             </a:extLst>
           </p:cNvPr>
@@ -8617,7 +8617,7 @@
           <p:cNvPr id="12" name="data-val-bar">
             <a:extLst xmlns:a="http://schemas.openxmlformats.org/drawingml/2006/main">
               <a:ext uri="{FF2B5EF4-FFF2-40B4-BE49-F238E27FC236}">
-                <a16:creationId xmlns:a16="http://schemas.microsoft.com/office/drawing/2014/main" id="{0CFA4A3D-8F4D-4987-90BC-86F7F3792E35}"/>
+                <a16:creationId xmlns:a16="http://schemas.microsoft.com/office/drawing/2014/main" id="{B313F34D-7C25-4625-A687-37CC3AED5BF7}"/>
               </a:ext>
             </a:extLst>
           </p:cNvPr>
@@ -8648,7 +8648,7 @@
           <p:cNvPr id="13" name="data-test-bar">
             <a:extLst xmlns:a="http://schemas.openxmlformats.org/drawingml/2006/main">
               <a:ext uri="{FF2B5EF4-FFF2-40B4-BE49-F238E27FC236}">
-                <a16:creationId xmlns:a16="http://schemas.microsoft.com/office/drawing/2014/main" id="{26182EA6-9826-4B92-BA78-F687E18C8701}"/>
+                <a16:creationId xmlns:a16="http://schemas.microsoft.com/office/drawing/2014/main" id="{1584E11C-D63B-49A5-A74E-D2AC3228F673}"/>
               </a:ext>
             </a:extLst>
           </p:cNvPr>
@@ -8679,7 +8679,7 @@
           <p:cNvPr id="14" name="data-train-label">
             <a:extLst xmlns:a="http://schemas.openxmlformats.org/drawingml/2006/main">
               <a:ext uri="{FF2B5EF4-FFF2-40B4-BE49-F238E27FC236}">
-                <a16:creationId xmlns:a16="http://schemas.microsoft.com/office/drawing/2014/main" id="{080C6513-6620-4E14-96EB-BF42264514DC}"/>
+                <a16:creationId xmlns:a16="http://schemas.microsoft.com/office/drawing/2014/main" id="{85658A8A-E963-4A4E-B4BF-771187EEFFDD}"/>
               </a:ext>
             </a:extLst>
           </p:cNvPr>
@@ -8746,7 +8746,7 @@
           <p:cNvPr id="15" name="data-val-label">
             <a:extLst xmlns:a="http://schemas.openxmlformats.org/drawingml/2006/main">
               <a:ext uri="{FF2B5EF4-FFF2-40B4-BE49-F238E27FC236}">
-                <a16:creationId xmlns:a16="http://schemas.microsoft.com/office/drawing/2014/main" id="{D983D0CB-B03E-4CAD-9E83-9B12993C3BB1}"/>
+                <a16:creationId xmlns:a16="http://schemas.microsoft.com/office/drawing/2014/main" id="{52E379BB-5B6F-42AD-813E-00405E4377CF}"/>
               </a:ext>
             </a:extLst>
           </p:cNvPr>
@@ -8813,7 +8813,7 @@
           <p:cNvPr id="16" name="data-test-label">
             <a:extLst xmlns:a="http://schemas.openxmlformats.org/drawingml/2006/main">
               <a:ext uri="{FF2B5EF4-FFF2-40B4-BE49-F238E27FC236}">
-                <a16:creationId xmlns:a16="http://schemas.microsoft.com/office/drawing/2014/main" id="{0C08551C-BF3D-448D-92A5-91FC5B544227}"/>
+                <a16:creationId xmlns:a16="http://schemas.microsoft.com/office/drawing/2014/main" id="{7F9E46BA-0FF1-4870-964C-3159B375AFEC}"/>
               </a:ext>
             </a:extLst>
           </p:cNvPr>
@@ -8880,7 +8880,7 @@
           <p:cNvPr id="17" name="data-audit-chain">
             <a:extLst xmlns:a="http://schemas.openxmlformats.org/drawingml/2006/main">
               <a:ext uri="{FF2B5EF4-FFF2-40B4-BE49-F238E27FC236}">
-                <a16:creationId xmlns:a16="http://schemas.microsoft.com/office/drawing/2014/main" id="{4A6BE085-3BA1-440F-A763-352F3143479D}"/>
+                <a16:creationId xmlns:a16="http://schemas.microsoft.com/office/drawing/2014/main" id="{154713BA-A04C-4C2F-B05A-1772FD5AE8CB}"/>
               </a:ext>
             </a:extLst>
           </p:cNvPr>
@@ -8930,7 +8930,7 @@
           <p:cNvPr id="18" name="data-boundary">
             <a:extLst xmlns:a="http://schemas.openxmlformats.org/drawingml/2006/main">
               <a:ext uri="{FF2B5EF4-FFF2-40B4-BE49-F238E27FC236}">
-                <a16:creationId xmlns:a16="http://schemas.microsoft.com/office/drawing/2014/main" id="{13444F3C-1871-48FA-8D1F-3D5B6CA3783A}"/>
+                <a16:creationId xmlns:a16="http://schemas.microsoft.com/office/drawing/2014/main" id="{3DFC1905-18C0-4EAE-BC87-4F55C647F983}"/>
               </a:ext>
             </a:extLst>
           </p:cNvPr>
@@ -8978,7 +8978,7 @@
     </p:spTree>
     <p:extLst>
       <p:ext uri="{BB962C8B-B14F-4D97-AF65-F5344CB8AC3E}">
-        <p14:creationId xmlns:p14="http://schemas.microsoft.com/office/powerpoint/2010/main" val="1154923637"/>
+        <p14:creationId xmlns:p14="http://schemas.microsoft.com/office/powerpoint/2010/main" val="948591020"/>
       </p:ext>
     </p:extLst>
   </p:cSld>
@@ -9009,7 +9009,7 @@
           <p:cNvPr id="16" name="top-rule-6">
             <a:extLst xmlns:a="http://schemas.openxmlformats.org/drawingml/2006/main">
               <a:ext uri="{FF2B5EF4-FFF2-40B4-BE49-F238E27FC236}">
-                <a16:creationId xmlns:a16="http://schemas.microsoft.com/office/drawing/2014/main" id="{8910A4E2-5403-4E5A-96A6-AF745CC8686C}"/>
+                <a16:creationId xmlns:a16="http://schemas.microsoft.com/office/drawing/2014/main" id="{ED470742-4DDD-459C-8F47-B02BE845222A}"/>
               </a:ext>
             </a:extLst>
           </p:cNvPr>
@@ -9040,7 +9040,7 @@
           <p:cNvPr id="2" name="kicker-6">
             <a:extLst xmlns:a="http://schemas.openxmlformats.org/drawingml/2006/main">
               <a:ext uri="{FF2B5EF4-FFF2-40B4-BE49-F238E27FC236}">
-                <a16:creationId xmlns:a16="http://schemas.microsoft.com/office/drawing/2014/main" id="{FB7FF024-7274-400E-9E9E-C077939F541F}"/>
+                <a16:creationId xmlns:a16="http://schemas.microsoft.com/office/drawing/2014/main" id="{7B56FBC3-FB51-4F9B-9FBE-0B7D200BB45E}"/>
               </a:ext>
             </a:extLst>
           </p:cNvPr>
@@ -9090,7 +9090,7 @@
           <p:cNvPr id="3" name="slide-title-6">
             <a:extLst xmlns:a="http://schemas.openxmlformats.org/drawingml/2006/main">
               <a:ext uri="{FF2B5EF4-FFF2-40B4-BE49-F238E27FC236}">
-                <a16:creationId xmlns:a16="http://schemas.microsoft.com/office/drawing/2014/main" id="{36AD75E0-B811-4181-9782-31EE066D7182}"/>
+                <a16:creationId xmlns:a16="http://schemas.microsoft.com/office/drawing/2014/main" id="{DD28685F-9789-4C69-91FE-9B6AC70D061C}"/>
               </a:ext>
             </a:extLst>
           </p:cNvPr>
@@ -9140,7 +9140,7 @@
           <p:cNvPr id="4" name="footer-rule-6">
             <a:extLst xmlns:a="http://schemas.openxmlformats.org/drawingml/2006/main">
               <a:ext uri="{FF2B5EF4-FFF2-40B4-BE49-F238E27FC236}">
-                <a16:creationId xmlns:a16="http://schemas.microsoft.com/office/drawing/2014/main" id="{FC0788A0-FFFA-403C-ABD8-DC0C8895D199}"/>
+                <a16:creationId xmlns:a16="http://schemas.microsoft.com/office/drawing/2014/main" id="{98EE32B3-3832-44D8-83BC-F012395EA752}"/>
               </a:ext>
             </a:extLst>
           </p:cNvPr>
@@ -9171,7 +9171,7 @@
           <p:cNvPr id="5" name="evidence-6">
             <a:extLst xmlns:a="http://schemas.openxmlformats.org/drawingml/2006/main">
               <a:ext uri="{FF2B5EF4-FFF2-40B4-BE49-F238E27FC236}">
-                <a16:creationId xmlns:a16="http://schemas.microsoft.com/office/drawing/2014/main" id="{647C4AE5-6DD6-46B3-802E-51EA6BB7E2EB}"/>
+                <a16:creationId xmlns:a16="http://schemas.microsoft.com/office/drawing/2014/main" id="{120CCF6E-95ED-43EB-9D68-3AA107AF1D96}"/>
               </a:ext>
             </a:extLst>
           </p:cNvPr>
@@ -9221,7 +9221,7 @@
           <p:cNvPr id="6" name="page-6">
             <a:extLst xmlns:a="http://schemas.openxmlformats.org/drawingml/2006/main">
               <a:ext uri="{FF2B5EF4-FFF2-40B4-BE49-F238E27FC236}">
-                <a16:creationId xmlns:a16="http://schemas.microsoft.com/office/drawing/2014/main" id="{3F085EB1-60C1-486C-BA90-A924C8A1AAFD}"/>
+                <a16:creationId xmlns:a16="http://schemas.microsoft.com/office/drawing/2014/main" id="{FA5F8736-F1F2-4C47-999A-B30A483F2110}"/>
               </a:ext>
             </a:extLst>
           </p:cNvPr>
@@ -9271,7 +9271,7 @@
           <p:cNvPr id="7" name="s06-models-claim-mark">
             <a:extLst xmlns:a="http://schemas.openxmlformats.org/drawingml/2006/main">
               <a:ext uri="{FF2B5EF4-FFF2-40B4-BE49-F238E27FC236}">
-                <a16:creationId xmlns:a16="http://schemas.microsoft.com/office/drawing/2014/main" id="{67ABB4B2-EF8E-4D8E-884C-7F18B2A129D9}"/>
+                <a16:creationId xmlns:a16="http://schemas.microsoft.com/office/drawing/2014/main" id="{9BF8AEE5-2770-46CC-ADCB-329D1566FE95}"/>
               </a:ext>
             </a:extLst>
           </p:cNvPr>
@@ -9302,7 +9302,7 @@
           <p:cNvPr id="8" name="s06-models-claim">
             <a:extLst xmlns:a="http://schemas.openxmlformats.org/drawingml/2006/main">
               <a:ext uri="{FF2B5EF4-FFF2-40B4-BE49-F238E27FC236}">
-                <a16:creationId xmlns:a16="http://schemas.microsoft.com/office/drawing/2014/main" id="{F3BAEDB1-2912-47AB-8E19-69A59CCC4466}"/>
+                <a16:creationId xmlns:a16="http://schemas.microsoft.com/office/drawing/2014/main" id="{5E00A69F-5433-42DB-8061-362587BC64AE}"/>
               </a:ext>
             </a:extLst>
           </p:cNvPr>
@@ -9352,7 +9352,7 @@
           <p:cNvPr id="9" name="models-divider">
             <a:extLst xmlns:a="http://schemas.openxmlformats.org/drawingml/2006/main">
               <a:ext uri="{FF2B5EF4-FFF2-40B4-BE49-F238E27FC236}">
-                <a16:creationId xmlns:a16="http://schemas.microsoft.com/office/drawing/2014/main" id="{51D9676C-B764-49F9-B660-A86E14DF677A}"/>
+                <a16:creationId xmlns:a16="http://schemas.microsoft.com/office/drawing/2014/main" id="{31AAAE27-B67E-49F3-8E67-3389C16612D8}"/>
               </a:ext>
             </a:extLst>
           </p:cNvPr>
@@ -9383,7 +9383,7 @@
           <p:cNvPr id="10" name="models-mit-name">
             <a:extLst xmlns:a="http://schemas.openxmlformats.org/drawingml/2006/main">
               <a:ext uri="{FF2B5EF4-FFF2-40B4-BE49-F238E27FC236}">
-                <a16:creationId xmlns:a16="http://schemas.microsoft.com/office/drawing/2014/main" id="{CA5EEBC1-8BBC-4164-A68F-39B79712F971}"/>
+                <a16:creationId xmlns:a16="http://schemas.microsoft.com/office/drawing/2014/main" id="{1DBE7CA3-1E16-4B7C-9C4C-2BCF10C43185}"/>
               </a:ext>
             </a:extLst>
           </p:cNvPr>
@@ -9433,7 +9433,7 @@
           <p:cNvPr id="11" name="models-mit-spec">
             <a:extLst xmlns:a="http://schemas.openxmlformats.org/drawingml/2006/main">
               <a:ext uri="{FF2B5EF4-FFF2-40B4-BE49-F238E27FC236}">
-                <a16:creationId xmlns:a16="http://schemas.microsoft.com/office/drawing/2014/main" id="{177FBA8F-A80F-4D86-BFEF-5DA6308DC0B0}"/>
+                <a16:creationId xmlns:a16="http://schemas.microsoft.com/office/drawing/2014/main" id="{CF1813B4-771F-48D1-B16B-42009B4A3529}"/>
               </a:ext>
             </a:extLst>
           </p:cNvPr>
@@ -9534,7 +9534,7 @@
           <p:cNvPr id="12" name="models-nnunet-name">
             <a:extLst xmlns:a="http://schemas.openxmlformats.org/drawingml/2006/main">
               <a:ext uri="{FF2B5EF4-FFF2-40B4-BE49-F238E27FC236}">
-                <a16:creationId xmlns:a16="http://schemas.microsoft.com/office/drawing/2014/main" id="{79C2B658-FE9C-43F4-8191-135189253106}"/>
+                <a16:creationId xmlns:a16="http://schemas.microsoft.com/office/drawing/2014/main" id="{B4DC32EE-CBB1-435F-A84C-FA2059A09F50}"/>
               </a:ext>
             </a:extLst>
           </p:cNvPr>
@@ -9584,7 +9584,7 @@
           <p:cNvPr id="13" name="models-nnunet-spec">
             <a:extLst xmlns:a="http://schemas.openxmlformats.org/drawingml/2006/main">
               <a:ext uri="{FF2B5EF4-FFF2-40B4-BE49-F238E27FC236}">
-                <a16:creationId xmlns:a16="http://schemas.microsoft.com/office/drawing/2014/main" id="{82FB95CC-0D4C-412E-82F4-B11D357F032C}"/>
+                <a16:creationId xmlns:a16="http://schemas.microsoft.com/office/drawing/2014/main" id="{51F6DFE9-797E-42E1-A9C8-848D00E0AF2D}"/>
               </a:ext>
             </a:extLst>
           </p:cNvPr>
@@ -9685,7 +9685,7 @@
           <p:cNvPr id="14" name="models-caution">
             <a:extLst xmlns:a="http://schemas.openxmlformats.org/drawingml/2006/main">
               <a:ext uri="{FF2B5EF4-FFF2-40B4-BE49-F238E27FC236}">
-                <a16:creationId xmlns:a16="http://schemas.microsoft.com/office/drawing/2014/main" id="{D35B6055-C4CA-42A9-9F81-06A832CA8C35}"/>
+                <a16:creationId xmlns:a16="http://schemas.microsoft.com/office/drawing/2014/main" id="{6329308F-D9C3-4BF6-9E04-18A277577B13}"/>
               </a:ext>
             </a:extLst>
           </p:cNvPr>
@@ -9716,7 +9716,7 @@
           <p:cNvPr id="15" name="models-caution-text">
             <a:extLst xmlns:a="http://schemas.openxmlformats.org/drawingml/2006/main">
               <a:ext uri="{FF2B5EF4-FFF2-40B4-BE49-F238E27FC236}">
-                <a16:creationId xmlns:a16="http://schemas.microsoft.com/office/drawing/2014/main" id="{5506525C-42AA-453E-A642-179A6B93BB3E}"/>
+                <a16:creationId xmlns:a16="http://schemas.microsoft.com/office/drawing/2014/main" id="{9460C4C5-71A4-40A0-A891-C197CCFDA66A}"/>
               </a:ext>
             </a:extLst>
           </p:cNvPr>
@@ -9764,7 +9764,7 @@
     </p:spTree>
     <p:extLst>
       <p:ext uri="{BB962C8B-B14F-4D97-AF65-F5344CB8AC3E}">
-        <p14:creationId xmlns:p14="http://schemas.microsoft.com/office/powerpoint/2010/main" val="428339643"/>
+        <p14:creationId xmlns:p14="http://schemas.microsoft.com/office/powerpoint/2010/main" val="1824978257"/>
       </p:ext>
     </p:extLst>
   </p:cSld>
@@ -9795,7 +9795,7 @@
           <p:cNvPr id="22" name="top-rule-7">
             <a:extLst xmlns:a="http://schemas.openxmlformats.org/drawingml/2006/main">
               <a:ext uri="{FF2B5EF4-FFF2-40B4-BE49-F238E27FC236}">
-                <a16:creationId xmlns:a16="http://schemas.microsoft.com/office/drawing/2014/main" id="{8A275F6E-3E08-4885-89FA-61B5CD28AEBF}"/>
+                <a16:creationId xmlns:a16="http://schemas.microsoft.com/office/drawing/2014/main" id="{158F892C-AEC3-48AB-BC41-EB4BE2BDA09D}"/>
               </a:ext>
             </a:extLst>
           </p:cNvPr>
@@ -9826,7 +9826,7 @@
           <p:cNvPr id="2" name="kicker-7">
             <a:extLst xmlns:a="http://schemas.openxmlformats.org/drawingml/2006/main">
               <a:ext uri="{FF2B5EF4-FFF2-40B4-BE49-F238E27FC236}">
-                <a16:creationId xmlns:a16="http://schemas.microsoft.com/office/drawing/2014/main" id="{1615CFC1-2331-4F7B-AC18-564D24A46AF1}"/>
+                <a16:creationId xmlns:a16="http://schemas.microsoft.com/office/drawing/2014/main" id="{02CAAB81-3036-4168-88C0-5B9742B2CDF6}"/>
               </a:ext>
             </a:extLst>
           </p:cNvPr>
@@ -9876,7 +9876,7 @@
           <p:cNvPr id="3" name="slide-title-7">
             <a:extLst xmlns:a="http://schemas.openxmlformats.org/drawingml/2006/main">
               <a:ext uri="{FF2B5EF4-FFF2-40B4-BE49-F238E27FC236}">
-                <a16:creationId xmlns:a16="http://schemas.microsoft.com/office/drawing/2014/main" id="{F15F020E-8813-440B-80A9-D2113DF1BE0E}"/>
+                <a16:creationId xmlns:a16="http://schemas.microsoft.com/office/drawing/2014/main" id="{6B0245F0-1F3E-4FFC-9C0E-949B24285D04}"/>
               </a:ext>
             </a:extLst>
           </p:cNvPr>
@@ -9888,7 +9888,7 @@
         <p:spPr>
           <a:xfrm xmlns:a="http://schemas.openxmlformats.org/drawingml/2006/main">
             <a:off x="647700" y="666750"/>
-            <a:ext cx="10287000" cy="704850"/>
+            <a:ext cx="10287000" cy="933450"/>
           </a:xfrm>
           <a:prstGeom xmlns:a="http://schemas.openxmlformats.org/drawingml/2006/main" prst="rect">
             <a:avLst/>
@@ -9904,14 +9904,14 @@
           <a:lstStyle xmlns:a="http://schemas.openxmlformats.org/drawingml/2006/main"/>
           <a:p xmlns:a="http://schemas.openxmlformats.org/drawingml/2006/main">
             <a:pPr algn="l">
-              <a:defRPr sz="2925" b="1" i="0">
-                <a:solidFill>
-                  <a:srgbClr val="1D211F"/>
-                </a:solidFill>
-              </a:defRPr>
-            </a:pPr>
-            <a:r>
-              <a:rPr sz="2925" b="1" i="0">
+              <a:defRPr sz="2625" b="1" i="0">
+                <a:solidFill>
+                  <a:srgbClr val="1D211F"/>
+                </a:solidFill>
+              </a:defRPr>
+            </a:pPr>
+            <a:r>
+              <a:rPr sz="2625" b="1" i="0">
                 <a:solidFill>
                   <a:srgbClr val="1D211F"/>
                 </a:solidFill>
@@ -9926,7 +9926,7 @@
           <p:cNvPr id="4" name="footer-rule-7">
             <a:extLst xmlns:a="http://schemas.openxmlformats.org/drawingml/2006/main">
               <a:ext uri="{FF2B5EF4-FFF2-40B4-BE49-F238E27FC236}">
-                <a16:creationId xmlns:a16="http://schemas.microsoft.com/office/drawing/2014/main" id="{64D41370-0B77-4C08-8F1B-BF327C7EF56E}"/>
+                <a16:creationId xmlns:a16="http://schemas.microsoft.com/office/drawing/2014/main" id="{288AF076-86C2-4A1B-972F-A3866F2A76C5}"/>
               </a:ext>
             </a:extLst>
           </p:cNvPr>
@@ -9957,7 +9957,7 @@
           <p:cNvPr id="5" name="evidence-7">
             <a:extLst xmlns:a="http://schemas.openxmlformats.org/drawingml/2006/main">
               <a:ext uri="{FF2B5EF4-FFF2-40B4-BE49-F238E27FC236}">
-                <a16:creationId xmlns:a16="http://schemas.microsoft.com/office/drawing/2014/main" id="{F2D99E75-272E-4E31-BF37-0F5E7E9EEBBB}"/>
+                <a16:creationId xmlns:a16="http://schemas.microsoft.com/office/drawing/2014/main" id="{40422B2C-8FBE-4B26-A603-D5ED9C0C2117}"/>
               </a:ext>
             </a:extLst>
           </p:cNvPr>
@@ -10007,7 +10007,7 @@
           <p:cNvPr id="6" name="page-7">
             <a:extLst xmlns:a="http://schemas.openxmlformats.org/drawingml/2006/main">
               <a:ext uri="{FF2B5EF4-FFF2-40B4-BE49-F238E27FC236}">
-                <a16:creationId xmlns:a16="http://schemas.microsoft.com/office/drawing/2014/main" id="{66C86069-0D49-4593-90F9-174A1A2272E2}"/>
+                <a16:creationId xmlns:a16="http://schemas.microsoft.com/office/drawing/2014/main" id="{D4344189-9AB1-4148-AB1B-1AC961863269}"/>
               </a:ext>
             </a:extLst>
           </p:cNvPr>
@@ -10057,18 +10057,18 @@
           <p:cNvPr id="7" name="s07-validation-claim-mark">
             <a:extLst xmlns:a="http://schemas.openxmlformats.org/drawingml/2006/main">
               <a:ext uri="{FF2B5EF4-FFF2-40B4-BE49-F238E27FC236}">
-                <a16:creationId xmlns:a16="http://schemas.microsoft.com/office/drawing/2014/main" id="{40EA5EDF-E538-46E8-853D-41396E46A8DC}"/>
-              </a:ext>
-            </a:extLst>
-          </p:cNvPr>
-          <p:cNvSpPr>
-            <a:spLocks xmlns:a="http://schemas.openxmlformats.org/drawingml/2006/main" noGrp="1"/>
-          </p:cNvSpPr>
-          <p:nvPr/>
-        </p:nvSpPr>
-        <p:spPr>
-          <a:xfrm xmlns:a="http://schemas.openxmlformats.org/drawingml/2006/main">
-            <a:off x="647700" y="1457325"/>
+                <a16:creationId xmlns:a16="http://schemas.microsoft.com/office/drawing/2014/main" id="{0E42929D-1283-4365-9A4F-7371B3393F2D}"/>
+              </a:ext>
+            </a:extLst>
+          </p:cNvPr>
+          <p:cNvSpPr>
+            <a:spLocks xmlns:a="http://schemas.openxmlformats.org/drawingml/2006/main" noGrp="1"/>
+          </p:cNvSpPr>
+          <p:nvPr/>
+        </p:nvSpPr>
+        <p:spPr>
+          <a:xfrm xmlns:a="http://schemas.openxmlformats.org/drawingml/2006/main">
+            <a:off x="647700" y="1724025"/>
             <a:ext cx="57150" cy="742950"/>
           </a:xfrm>
           <a:prstGeom xmlns:a="http://schemas.openxmlformats.org/drawingml/2006/main" prst="rect">
@@ -10088,18 +10088,18 @@
           <p:cNvPr id="8" name="s07-validation-claim">
             <a:extLst xmlns:a="http://schemas.openxmlformats.org/drawingml/2006/main">
               <a:ext uri="{FF2B5EF4-FFF2-40B4-BE49-F238E27FC236}">
-                <a16:creationId xmlns:a16="http://schemas.microsoft.com/office/drawing/2014/main" id="{459EC076-DE04-4A5D-B592-E49ECD066011}"/>
-              </a:ext>
-            </a:extLst>
-          </p:cNvPr>
-          <p:cNvSpPr>
-            <a:spLocks xmlns:a="http://schemas.openxmlformats.org/drawingml/2006/main" noGrp="1"/>
-          </p:cNvSpPr>
-          <p:nvPr/>
-        </p:nvSpPr>
-        <p:spPr>
-          <a:xfrm xmlns:a="http://schemas.openxmlformats.org/drawingml/2006/main">
-            <a:off x="857250" y="1428750"/>
+                <a16:creationId xmlns:a16="http://schemas.microsoft.com/office/drawing/2014/main" id="{64580F9A-3A67-485F-80C3-7A02E29D909F}"/>
+              </a:ext>
+            </a:extLst>
+          </p:cNvPr>
+          <p:cNvSpPr>
+            <a:spLocks xmlns:a="http://schemas.openxmlformats.org/drawingml/2006/main" noGrp="1"/>
+          </p:cNvSpPr>
+          <p:nvPr/>
+        </p:nvSpPr>
+        <p:spPr>
+          <a:xfrm xmlns:a="http://schemas.openxmlformats.org/drawingml/2006/main">
+            <a:off x="857250" y="1695450"/>
             <a:ext cx="10191750" cy="857250"/>
           </a:xfrm>
           <a:prstGeom xmlns:a="http://schemas.openxmlformats.org/drawingml/2006/main" prst="rect">
@@ -10138,7 +10138,7 @@
           <p:cNvPr id="9" name="validation-label-0">
             <a:extLst xmlns:a="http://schemas.openxmlformats.org/drawingml/2006/main">
               <a:ext uri="{FF2B5EF4-FFF2-40B4-BE49-F238E27FC236}">
-                <a16:creationId xmlns:a16="http://schemas.microsoft.com/office/drawing/2014/main" id="{23388C2C-98FF-439C-961D-D8580A3CBA46}"/>
+                <a16:creationId xmlns:a16="http://schemas.microsoft.com/office/drawing/2014/main" id="{E64D0292-9B67-4B9D-8AFE-C589C23FE89C}"/>
               </a:ext>
             </a:extLst>
           </p:cNvPr>
@@ -10188,7 +10188,7 @@
           <p:cNvPr id="10" name="validation-a-value-0">
             <a:extLst xmlns:a="http://schemas.openxmlformats.org/drawingml/2006/main">
               <a:ext uri="{FF2B5EF4-FFF2-40B4-BE49-F238E27FC236}">
-                <a16:creationId xmlns:a16="http://schemas.microsoft.com/office/drawing/2014/main" id="{BA61BD53-823B-4F42-9255-84B0508926AA}"/>
+                <a16:creationId xmlns:a16="http://schemas.microsoft.com/office/drawing/2014/main" id="{D24C4A43-3F8D-40D7-B6CD-21E972FAC553}"/>
               </a:ext>
             </a:extLst>
           </p:cNvPr>
@@ -10238,7 +10238,7 @@
           <p:cNvPr id="11" name="validation-a-bar-0">
             <a:extLst xmlns:a="http://schemas.openxmlformats.org/drawingml/2006/main">
               <a:ext uri="{FF2B5EF4-FFF2-40B4-BE49-F238E27FC236}">
-                <a16:creationId xmlns:a16="http://schemas.microsoft.com/office/drawing/2014/main" id="{F688EB2D-5DF7-4AC4-917B-83E443C37EAF}"/>
+                <a16:creationId xmlns:a16="http://schemas.microsoft.com/office/drawing/2014/main" id="{438AE2A6-8290-4FD6-923A-D53B6A5B3A83}"/>
               </a:ext>
             </a:extLst>
           </p:cNvPr>
@@ -10269,7 +10269,7 @@
           <p:cNvPr id="12" name="validation-b-value-0">
             <a:extLst xmlns:a="http://schemas.openxmlformats.org/drawingml/2006/main">
               <a:ext uri="{FF2B5EF4-FFF2-40B4-BE49-F238E27FC236}">
-                <a16:creationId xmlns:a16="http://schemas.microsoft.com/office/drawing/2014/main" id="{0015CDA8-A1C3-42E8-B8A6-0EA8A26ECBD2}"/>
+                <a16:creationId xmlns:a16="http://schemas.microsoft.com/office/drawing/2014/main" id="{194A974D-9746-408D-9D62-0290FE8B7448}"/>
               </a:ext>
             </a:extLst>
           </p:cNvPr>
@@ -10319,7 +10319,7 @@
           <p:cNvPr id="13" name="validation-b-bar-0">
             <a:extLst xmlns:a="http://schemas.openxmlformats.org/drawingml/2006/main">
               <a:ext uri="{FF2B5EF4-FFF2-40B4-BE49-F238E27FC236}">
-                <a16:creationId xmlns:a16="http://schemas.microsoft.com/office/drawing/2014/main" id="{A3016D91-600B-41FA-9ECA-5868097D1DF4}"/>
+                <a16:creationId xmlns:a16="http://schemas.microsoft.com/office/drawing/2014/main" id="{7D493623-6756-4BCF-B35A-15147AA6D850}"/>
               </a:ext>
             </a:extLst>
           </p:cNvPr>
@@ -10350,7 +10350,7 @@
           <p:cNvPr id="14" name="validation-label-1">
             <a:extLst xmlns:a="http://schemas.openxmlformats.org/drawingml/2006/main">
               <a:ext uri="{FF2B5EF4-FFF2-40B4-BE49-F238E27FC236}">
-                <a16:creationId xmlns:a16="http://schemas.microsoft.com/office/drawing/2014/main" id="{B5E32CF1-8D75-42FA-87CF-245FB054FD83}"/>
+                <a16:creationId xmlns:a16="http://schemas.microsoft.com/office/drawing/2014/main" id="{9E4FBE7A-FD3D-4AE8-8DD1-CDBD3E515CED}"/>
               </a:ext>
             </a:extLst>
           </p:cNvPr>
@@ -10400,7 +10400,7 @@
           <p:cNvPr id="15" name="validation-a-value-1">
             <a:extLst xmlns:a="http://schemas.openxmlformats.org/drawingml/2006/main">
               <a:ext uri="{FF2B5EF4-FFF2-40B4-BE49-F238E27FC236}">
-                <a16:creationId xmlns:a16="http://schemas.microsoft.com/office/drawing/2014/main" id="{B08FD818-1AD1-46B2-AFA2-B9F3EC1504E4}"/>
+                <a16:creationId xmlns:a16="http://schemas.microsoft.com/office/drawing/2014/main" id="{216E6432-91FA-4DBB-9F0A-B4E01C94B0E3}"/>
               </a:ext>
             </a:extLst>
           </p:cNvPr>
@@ -10450,7 +10450,7 @@
           <p:cNvPr id="16" name="validation-a-bar-1">
             <a:extLst xmlns:a="http://schemas.openxmlformats.org/drawingml/2006/main">
               <a:ext uri="{FF2B5EF4-FFF2-40B4-BE49-F238E27FC236}">
-                <a16:creationId xmlns:a16="http://schemas.microsoft.com/office/drawing/2014/main" id="{32C6E151-CF68-455A-AB3F-77876E0A7130}"/>
+                <a16:creationId xmlns:a16="http://schemas.microsoft.com/office/drawing/2014/main" id="{F94220E5-D48B-48B3-B202-B48FDA318F8A}"/>
               </a:ext>
             </a:extLst>
           </p:cNvPr>
@@ -10481,7 +10481,7 @@
           <p:cNvPr id="17" name="validation-b-value-1">
             <a:extLst xmlns:a="http://schemas.openxmlformats.org/drawingml/2006/main">
               <a:ext uri="{FF2B5EF4-FFF2-40B4-BE49-F238E27FC236}">
-                <a16:creationId xmlns:a16="http://schemas.microsoft.com/office/drawing/2014/main" id="{D5E5AB33-E4CE-4569-A0B8-C465BEB0BF3E}"/>
+                <a16:creationId xmlns:a16="http://schemas.microsoft.com/office/drawing/2014/main" id="{A3FFD999-F840-45C5-8937-F17778E81FD3}"/>
               </a:ext>
             </a:extLst>
           </p:cNvPr>
@@ -10531,7 +10531,7 @@
           <p:cNvPr id="18" name="validation-b-bar-1">
             <a:extLst xmlns:a="http://schemas.openxmlformats.org/drawingml/2006/main">
               <a:ext uri="{FF2B5EF4-FFF2-40B4-BE49-F238E27FC236}">
-                <a16:creationId xmlns:a16="http://schemas.microsoft.com/office/drawing/2014/main" id="{EE17D9A5-3882-4E65-8168-F9E28A8370D7}"/>
+                <a16:creationId xmlns:a16="http://schemas.microsoft.com/office/drawing/2014/main" id="{3C5DB701-9F38-48AB-9FDC-373B9CEBE069}"/>
               </a:ext>
             </a:extLst>
           </p:cNvPr>
@@ -10562,7 +10562,7 @@
           <p:cNvPr id="19" name="validation-legend">
             <a:extLst xmlns:a="http://schemas.openxmlformats.org/drawingml/2006/main">
               <a:ext uri="{FF2B5EF4-FFF2-40B4-BE49-F238E27FC236}">
-                <a16:creationId xmlns:a16="http://schemas.microsoft.com/office/drawing/2014/main" id="{77C0A763-A079-483D-B1D7-94B036F76164}"/>
+                <a16:creationId xmlns:a16="http://schemas.microsoft.com/office/drawing/2014/main" id="{B46C45E5-9F61-4747-946C-B4384D35E123}"/>
               </a:ext>
             </a:extLst>
           </p:cNvPr>
@@ -10612,7 +10612,7 @@
           <p:cNvPr id="20" name="validation-limit">
             <a:extLst xmlns:a="http://schemas.openxmlformats.org/drawingml/2006/main">
               <a:ext uri="{FF2B5EF4-FFF2-40B4-BE49-F238E27FC236}">
-                <a16:creationId xmlns:a16="http://schemas.microsoft.com/office/drawing/2014/main" id="{8F3E3B44-DA03-4DED-BF35-800A326938FE}"/>
+                <a16:creationId xmlns:a16="http://schemas.microsoft.com/office/drawing/2014/main" id="{6F29E82F-E564-4701-8384-D1081ED3B06E}"/>
               </a:ext>
             </a:extLst>
           </p:cNvPr>
@@ -10696,7 +10696,7 @@
           <p:cNvPr id="21" name="validation-precision">
             <a:extLst xmlns:a="http://schemas.openxmlformats.org/drawingml/2006/main">
               <a:ext uri="{FF2B5EF4-FFF2-40B4-BE49-F238E27FC236}">
-                <a16:creationId xmlns:a16="http://schemas.microsoft.com/office/drawing/2014/main" id="{6543E895-62D7-480B-B798-928A55268C8D}"/>
+                <a16:creationId xmlns:a16="http://schemas.microsoft.com/office/drawing/2014/main" id="{F4BBEF83-B7B8-49E0-B444-F52F4D1B98AA}"/>
               </a:ext>
             </a:extLst>
           </p:cNvPr>
@@ -10744,7 +10744,7 @@
     </p:spTree>
     <p:extLst>
       <p:ext uri="{BB962C8B-B14F-4D97-AF65-F5344CB8AC3E}">
-        <p14:creationId xmlns:p14="http://schemas.microsoft.com/office/powerpoint/2010/main" val="304236190"/>
+        <p14:creationId xmlns:p14="http://schemas.microsoft.com/office/powerpoint/2010/main" val="431385755"/>
       </p:ext>
     </p:extLst>
   </p:cSld>
@@ -10775,7 +10775,7 @@
           <p:cNvPr id="31" name="top-rule-8">
             <a:extLst xmlns:a="http://schemas.openxmlformats.org/drawingml/2006/main">
               <a:ext uri="{FF2B5EF4-FFF2-40B4-BE49-F238E27FC236}">
-                <a16:creationId xmlns:a16="http://schemas.microsoft.com/office/drawing/2014/main" id="{21F8AE49-C387-4C69-BF5E-8D03F0BD37E1}"/>
+                <a16:creationId xmlns:a16="http://schemas.microsoft.com/office/drawing/2014/main" id="{08EB799C-9D9C-4838-8093-EE1B7FD9E316}"/>
               </a:ext>
             </a:extLst>
           </p:cNvPr>
@@ -10806,7 +10806,7 @@
           <p:cNvPr id="2" name="kicker-8">
             <a:extLst xmlns:a="http://schemas.openxmlformats.org/drawingml/2006/main">
               <a:ext uri="{FF2B5EF4-FFF2-40B4-BE49-F238E27FC236}">
-                <a16:creationId xmlns:a16="http://schemas.microsoft.com/office/drawing/2014/main" id="{3BC0CF5A-5F02-475E-8B68-D8EDFA886476}"/>
+                <a16:creationId xmlns:a16="http://schemas.microsoft.com/office/drawing/2014/main" id="{AF007E0C-E344-4F37-8206-6CEB9E5EB61B}"/>
               </a:ext>
             </a:extLst>
           </p:cNvPr>
@@ -10856,7 +10856,7 @@
           <p:cNvPr id="3" name="slide-title-8">
             <a:extLst xmlns:a="http://schemas.openxmlformats.org/drawingml/2006/main">
               <a:ext uri="{FF2B5EF4-FFF2-40B4-BE49-F238E27FC236}">
-                <a16:creationId xmlns:a16="http://schemas.microsoft.com/office/drawing/2014/main" id="{1DB901EA-40CF-435B-A889-0CDC78AA8BE3}"/>
+                <a16:creationId xmlns:a16="http://schemas.microsoft.com/office/drawing/2014/main" id="{A7941E1C-4EF8-4C2F-A694-9F11C186A003}"/>
               </a:ext>
             </a:extLst>
           </p:cNvPr>
@@ -10906,7 +10906,7 @@
           <p:cNvPr id="4" name="footer-rule-8">
             <a:extLst xmlns:a="http://schemas.openxmlformats.org/drawingml/2006/main">
               <a:ext uri="{FF2B5EF4-FFF2-40B4-BE49-F238E27FC236}">
-                <a16:creationId xmlns:a16="http://schemas.microsoft.com/office/drawing/2014/main" id="{19AF13EA-EA3D-4A19-BEA0-9E6F23EBFC11}"/>
+                <a16:creationId xmlns:a16="http://schemas.microsoft.com/office/drawing/2014/main" id="{B3C44942-4701-4773-B89F-3D9AA37C2A81}"/>
               </a:ext>
             </a:extLst>
           </p:cNvPr>
@@ -10937,7 +10937,7 @@
           <p:cNvPr id="5" name="evidence-8">
             <a:extLst xmlns:a="http://schemas.openxmlformats.org/drawingml/2006/main">
               <a:ext uri="{FF2B5EF4-FFF2-40B4-BE49-F238E27FC236}">
-                <a16:creationId xmlns:a16="http://schemas.microsoft.com/office/drawing/2014/main" id="{BDFE48E0-D609-4E12-BA2B-552FD6BAE7D2}"/>
+                <a16:creationId xmlns:a16="http://schemas.microsoft.com/office/drawing/2014/main" id="{5FD349F9-D2D5-4E22-AB4A-B345913D5B8C}"/>
               </a:ext>
             </a:extLst>
           </p:cNvPr>
@@ -10987,7 +10987,7 @@
           <p:cNvPr id="6" name="page-8">
             <a:extLst xmlns:a="http://schemas.openxmlformats.org/drawingml/2006/main">
               <a:ext uri="{FF2B5EF4-FFF2-40B4-BE49-F238E27FC236}">
-                <a16:creationId xmlns:a16="http://schemas.microsoft.com/office/drawing/2014/main" id="{C88FE770-D084-45E7-B0AE-8E18CF3B401E}"/>
+                <a16:creationId xmlns:a16="http://schemas.microsoft.com/office/drawing/2014/main" id="{6D447824-6B3B-48A7-9F5D-E306E883FA86}"/>
               </a:ext>
             </a:extLst>
           </p:cNvPr>
@@ -11037,7 +11037,7 @@
           <p:cNvPr id="7" name="s08-ablation-design-claim-mark">
             <a:extLst xmlns:a="http://schemas.openxmlformats.org/drawingml/2006/main">
               <a:ext uri="{FF2B5EF4-FFF2-40B4-BE49-F238E27FC236}">
-                <a16:creationId xmlns:a16="http://schemas.microsoft.com/office/drawing/2014/main" id="{72932D8C-0AB4-49D5-9646-B33D3C6AD32C}"/>
+                <a16:creationId xmlns:a16="http://schemas.microsoft.com/office/drawing/2014/main" id="{41A2233D-FA3A-4315-BD22-A75EE34D95BC}"/>
               </a:ext>
             </a:extLst>
           </p:cNvPr>
@@ -11068,7 +11068,7 @@
           <p:cNvPr id="8" name="s08-ablation-design-claim">
             <a:extLst xmlns:a="http://schemas.openxmlformats.org/drawingml/2006/main">
               <a:ext uri="{FF2B5EF4-FFF2-40B4-BE49-F238E27FC236}">
-                <a16:creationId xmlns:a16="http://schemas.microsoft.com/office/drawing/2014/main" id="{3989A28D-E2E5-42AE-BC9C-12EE5F4A5E48}"/>
+                <a16:creationId xmlns:a16="http://schemas.microsoft.com/office/drawing/2014/main" id="{4DE5871D-2F30-4299-BF76-CB2F5A798DD8}"/>
               </a:ext>
             </a:extLst>
           </p:cNvPr>
@@ -11118,7 +11118,7 @@
           <p:cNvPr id="9" name="ablation-input-stem">
             <a:extLst xmlns:a="http://schemas.openxmlformats.org/drawingml/2006/main">
               <a:ext uri="{FF2B5EF4-FFF2-40B4-BE49-F238E27FC236}">
-                <a16:creationId xmlns:a16="http://schemas.microsoft.com/office/drawing/2014/main" id="{E2EE9148-8E2C-4064-AB01-414972BE0F7D}"/>
+                <a16:creationId xmlns:a16="http://schemas.microsoft.com/office/drawing/2014/main" id="{7221374F-02E7-41C5-A1CD-C2B5390FF1FE}"/>
               </a:ext>
             </a:extLst>
           </p:cNvPr>
@@ -11149,7 +11149,7 @@
           <p:cNvPr id="10" name="ablation-control-edge">
             <a:extLst xmlns:a="http://schemas.openxmlformats.org/drawingml/2006/main">
               <a:ext uri="{FF2B5EF4-FFF2-40B4-BE49-F238E27FC236}">
-                <a16:creationId xmlns:a16="http://schemas.microsoft.com/office/drawing/2014/main" id="{51C076CA-374A-43CF-8A02-448814590123}"/>
+                <a16:creationId xmlns:a16="http://schemas.microsoft.com/office/drawing/2014/main" id="{835CE2CF-41DC-48B6-AB3F-3B6CBBFD1A8E}"/>
               </a:ext>
             </a:extLst>
           </p:cNvPr>
@@ -11180,7 +11180,7 @@
           <p:cNvPr id="11" name="ablation-control-out">
             <a:extLst xmlns:a="http://schemas.openxmlformats.org/drawingml/2006/main">
               <a:ext uri="{FF2B5EF4-FFF2-40B4-BE49-F238E27FC236}">
-                <a16:creationId xmlns:a16="http://schemas.microsoft.com/office/drawing/2014/main" id="{DA29B5D3-C53C-4862-9806-C672BB4D286F}"/>
+                <a16:creationId xmlns:a16="http://schemas.microsoft.com/office/drawing/2014/main" id="{B11442BB-DDE9-4C06-A40A-DCF1367E1011}"/>
               </a:ext>
             </a:extLst>
           </p:cNvPr>
@@ -11211,7 +11211,7 @@
           <p:cNvPr id="12" name="ablation-candidate-out">
             <a:extLst xmlns:a="http://schemas.openxmlformats.org/drawingml/2006/main">
               <a:ext uri="{FF2B5EF4-FFF2-40B4-BE49-F238E27FC236}">
-                <a16:creationId xmlns:a16="http://schemas.microsoft.com/office/drawing/2014/main" id="{8E114127-366A-4783-8416-8BDDA4F4248D}"/>
+                <a16:creationId xmlns:a16="http://schemas.microsoft.com/office/drawing/2014/main" id="{E3CF3F11-F26F-4F0F-9AE4-7382DE0AFAC8}"/>
               </a:ext>
             </a:extLst>
           </p:cNvPr>
@@ -11242,7 +11242,7 @@
           <p:cNvPr id="13" name="ablation-merge-a">
             <a:extLst xmlns:a="http://schemas.openxmlformats.org/drawingml/2006/main">
               <a:ext uri="{FF2B5EF4-FFF2-40B4-BE49-F238E27FC236}">
-                <a16:creationId xmlns:a16="http://schemas.microsoft.com/office/drawing/2014/main" id="{64F78FC4-C666-4756-A0B8-9B7F2697DF09}"/>
+                <a16:creationId xmlns:a16="http://schemas.microsoft.com/office/drawing/2014/main" id="{B02A1F9E-2A78-4091-A2AA-74AF166BD971}"/>
               </a:ext>
             </a:extLst>
           </p:cNvPr>
@@ -11273,7 +11273,7 @@
           <p:cNvPr id="14" name="ablation-merge-b">
             <a:extLst xmlns:a="http://schemas.openxmlformats.org/drawingml/2006/main">
               <a:ext uri="{FF2B5EF4-FFF2-40B4-BE49-F238E27FC236}">
-                <a16:creationId xmlns:a16="http://schemas.microsoft.com/office/drawing/2014/main" id="{31F915E3-99A8-4767-AAA4-111369970E58}"/>
+                <a16:creationId xmlns:a16="http://schemas.microsoft.com/office/drawing/2014/main" id="{31799108-FE1D-42FB-8F5F-269F60D15B2F}"/>
               </a:ext>
             </a:extLst>
           </p:cNvPr>
@@ -11304,7 +11304,7 @@
           <p:cNvPr id="15" name="ablation-merge-v">
             <a:extLst xmlns:a="http://schemas.openxmlformats.org/drawingml/2006/main">
               <a:ext uri="{FF2B5EF4-FFF2-40B4-BE49-F238E27FC236}">
-                <a16:creationId xmlns:a16="http://schemas.microsoft.com/office/drawing/2014/main" id="{37F71C6D-6BF4-4735-AB64-38A16F07F5A8}"/>
+                <a16:creationId xmlns:a16="http://schemas.microsoft.com/office/drawing/2014/main" id="{40A80B33-C821-4833-9D95-88BA04F0692E}"/>
               </a:ext>
             </a:extLst>
           </p:cNvPr>
@@ -11335,7 +11335,7 @@
           <p:cNvPr id="16" name="ablation-merge-out">
             <a:extLst xmlns:a="http://schemas.openxmlformats.org/drawingml/2006/main">
               <a:ext uri="{FF2B5EF4-FFF2-40B4-BE49-F238E27FC236}">
-                <a16:creationId xmlns:a16="http://schemas.microsoft.com/office/drawing/2014/main" id="{CF11AEBB-4BDF-4546-AA0D-51B491E16D15}"/>
+                <a16:creationId xmlns:a16="http://schemas.microsoft.com/office/drawing/2014/main" id="{BAD73F9F-7241-483D-BE8F-03F7186784DC}"/>
               </a:ext>
             </a:extLst>
           </p:cNvPr>
@@ -11366,7 +11366,7 @@
           <p:cNvPr id="17" name="ablation-input">
             <a:extLst xmlns:a="http://schemas.openxmlformats.org/drawingml/2006/main">
               <a:ext uri="{FF2B5EF4-FFF2-40B4-BE49-F238E27FC236}">
-                <a16:creationId xmlns:a16="http://schemas.microsoft.com/office/drawing/2014/main" id="{AE330CC7-694F-4398-90D8-62CE14B5A855}"/>
+                <a16:creationId xmlns:a16="http://schemas.microsoft.com/office/drawing/2014/main" id="{E821231B-4865-43CF-AAD3-6C979410D96A}"/>
               </a:ext>
             </a:extLst>
           </p:cNvPr>
@@ -11401,7 +11401,7 @@
           <p:cNvPr id="18" name="ablation-input-text">
             <a:extLst xmlns:a="http://schemas.openxmlformats.org/drawingml/2006/main">
               <a:ext uri="{FF2B5EF4-FFF2-40B4-BE49-F238E27FC236}">
-                <a16:creationId xmlns:a16="http://schemas.microsoft.com/office/drawing/2014/main" id="{7BA4BE2D-FF45-4F58-9CC8-9DD966BCAF48}"/>
+                <a16:creationId xmlns:a16="http://schemas.microsoft.com/office/drawing/2014/main" id="{6F6DC7A9-B7AD-48E1-BA5C-D9A9297796D7}"/>
               </a:ext>
             </a:extLst>
           </p:cNvPr>
@@ -11468,7 +11468,7 @@
           <p:cNvPr id="19" name="ablation-control">
             <a:extLst xmlns:a="http://schemas.openxmlformats.org/drawingml/2006/main">
               <a:ext uri="{FF2B5EF4-FFF2-40B4-BE49-F238E27FC236}">
-                <a16:creationId xmlns:a16="http://schemas.microsoft.com/office/drawing/2014/main" id="{1ED4937D-5A0A-4FA4-BD16-C4E3D2FB14C5}"/>
+                <a16:creationId xmlns:a16="http://schemas.microsoft.com/office/drawing/2014/main" id="{FCBA1EE2-DAD7-417C-B81C-4802E4B19C36}"/>
               </a:ext>
             </a:extLst>
           </p:cNvPr>
@@ -11501,7 +11501,7 @@
           <p:cNvPr id="20" name="ablation-control-text">
             <a:extLst xmlns:a="http://schemas.openxmlformats.org/drawingml/2006/main">
               <a:ext uri="{FF2B5EF4-FFF2-40B4-BE49-F238E27FC236}">
-                <a16:creationId xmlns:a16="http://schemas.microsoft.com/office/drawing/2014/main" id="{1A8F67E8-1460-4523-BB06-E0F80A48EBE7}"/>
+                <a16:creationId xmlns:a16="http://schemas.microsoft.com/office/drawing/2014/main" id="{DF5960E9-CFB5-4B8F-8D83-D9B8B03134E2}"/>
               </a:ext>
             </a:extLst>
           </p:cNvPr>
@@ -11568,7 +11568,7 @@
           <p:cNvPr id="21" name="ablation-candidate">
             <a:extLst xmlns:a="http://schemas.openxmlformats.org/drawingml/2006/main">
               <a:ext uri="{FF2B5EF4-FFF2-40B4-BE49-F238E27FC236}">
-                <a16:creationId xmlns:a16="http://schemas.microsoft.com/office/drawing/2014/main" id="{7EF9BD51-EF63-40CD-9FDF-0A88B4651432}"/>
+                <a16:creationId xmlns:a16="http://schemas.microsoft.com/office/drawing/2014/main" id="{92EED6B4-8141-4BFA-A87E-977798622432}"/>
               </a:ext>
             </a:extLst>
           </p:cNvPr>
@@ -11601,7 +11601,7 @@
           <p:cNvPr id="22" name="ablation-candidate-text">
             <a:extLst xmlns:a="http://schemas.openxmlformats.org/drawingml/2006/main">
               <a:ext uri="{FF2B5EF4-FFF2-40B4-BE49-F238E27FC236}">
-                <a16:creationId xmlns:a16="http://schemas.microsoft.com/office/drawing/2014/main" id="{E6EB77CA-9083-47D4-9EC5-46BF3FFDEA3D}"/>
+                <a16:creationId xmlns:a16="http://schemas.microsoft.com/office/drawing/2014/main" id="{E06E8A42-97D2-467A-B20F-74D5EBB3E92A}"/>
               </a:ext>
             </a:extLst>
           </p:cNvPr>
@@ -11668,7 +11668,7 @@
           <p:cNvPr id="23" name="ablation-compare">
             <a:extLst xmlns:a="http://schemas.openxmlformats.org/drawingml/2006/main">
               <a:ext uri="{FF2B5EF4-FFF2-40B4-BE49-F238E27FC236}">
-                <a16:creationId xmlns:a16="http://schemas.microsoft.com/office/drawing/2014/main" id="{8151BF27-1B61-49DC-8178-F535FFCC5F07}"/>
+                <a16:creationId xmlns:a16="http://schemas.microsoft.com/office/drawing/2014/main" id="{F2C24C8B-3C0A-4598-A920-EE5B1E7B067E}"/>
               </a:ext>
             </a:extLst>
           </p:cNvPr>
@@ -11701,7 +11701,7 @@
           <p:cNvPr id="24" name="ablation-compare-text">
             <a:extLst xmlns:a="http://schemas.openxmlformats.org/drawingml/2006/main">
               <a:ext uri="{FF2B5EF4-FFF2-40B4-BE49-F238E27FC236}">
-                <a16:creationId xmlns:a16="http://schemas.microsoft.com/office/drawing/2014/main" id="{9A3CFA8F-644F-447A-92F4-78C7A89C8B60}"/>
+                <a16:creationId xmlns:a16="http://schemas.microsoft.com/office/drawing/2014/main" id="{CDAE21E9-2931-4E80-B3CE-780EE000FF8C}"/>
               </a:ext>
             </a:extLst>
           </p:cNvPr>
@@ -11768,7 +11768,7 @@
           <p:cNvPr id="25" name="s08-ablation-design-fit groups-value">
             <a:extLst xmlns:a="http://schemas.openxmlformats.org/drawingml/2006/main">
               <a:ext uri="{FF2B5EF4-FFF2-40B4-BE49-F238E27FC236}">
-                <a16:creationId xmlns:a16="http://schemas.microsoft.com/office/drawing/2014/main" id="{A1B8BF9C-995A-4799-9072-19F41F5903D6}"/>
+                <a16:creationId xmlns:a16="http://schemas.microsoft.com/office/drawing/2014/main" id="{7A7DF987-34FE-4155-A56F-C20CA8F5788E}"/>
               </a:ext>
             </a:extLst>
           </p:cNvPr>
@@ -11818,7 +11818,7 @@
           <p:cNvPr id="26" name="s08-ablation-design-fit groups-label">
             <a:extLst xmlns:a="http://schemas.openxmlformats.org/drawingml/2006/main">
               <a:ext uri="{FF2B5EF4-FFF2-40B4-BE49-F238E27FC236}">
-                <a16:creationId xmlns:a16="http://schemas.microsoft.com/office/drawing/2014/main" id="{75D330DA-AD8D-43CC-971B-E286414881FF}"/>
+                <a16:creationId xmlns:a16="http://schemas.microsoft.com/office/drawing/2014/main" id="{FB3075AF-F4A3-45A4-970A-D0F2640266B6}"/>
               </a:ext>
             </a:extLst>
           </p:cNvPr>
@@ -11868,7 +11868,7 @@
           <p:cNvPr id="27" name="s08-ablation-design-holdout groups-value">
             <a:extLst xmlns:a="http://schemas.openxmlformats.org/drawingml/2006/main">
               <a:ext uri="{FF2B5EF4-FFF2-40B4-BE49-F238E27FC236}">
-                <a16:creationId xmlns:a16="http://schemas.microsoft.com/office/drawing/2014/main" id="{2B6074A9-3586-4727-9F3C-EAF0387B04EE}"/>
+                <a16:creationId xmlns:a16="http://schemas.microsoft.com/office/drawing/2014/main" id="{1A8785AE-E12D-4CCF-B4DE-D146A4754CEB}"/>
               </a:ext>
             </a:extLst>
           </p:cNvPr>
@@ -11918,7 +11918,7 @@
           <p:cNvPr id="28" name="s08-ablation-design-holdout groups-label">
             <a:extLst xmlns:a="http://schemas.openxmlformats.org/drawingml/2006/main">
               <a:ext uri="{FF2B5EF4-FFF2-40B4-BE49-F238E27FC236}">
-                <a16:creationId xmlns:a16="http://schemas.microsoft.com/office/drawing/2014/main" id="{F9A24907-DEBD-4BEC-B2BB-5FBF087A4F56}"/>
+                <a16:creationId xmlns:a16="http://schemas.microsoft.com/office/drawing/2014/main" id="{A732B2FA-4CA9-4FDB-887B-AFB3BC6EAF9B}"/>
               </a:ext>
             </a:extLst>
           </p:cNvPr>
@@ -11968,7 +11968,7 @@
           <p:cNvPr id="29" name="s08-ablation-design-paired seeds-value">
             <a:extLst xmlns:a="http://schemas.openxmlformats.org/drawingml/2006/main">
               <a:ext uri="{FF2B5EF4-FFF2-40B4-BE49-F238E27FC236}">
-                <a16:creationId xmlns:a16="http://schemas.microsoft.com/office/drawing/2014/main" id="{A2808E38-FD52-4FB3-8ED9-25C8C66487FD}"/>
+                <a16:creationId xmlns:a16="http://schemas.microsoft.com/office/drawing/2014/main" id="{714A0684-FDC5-4920-908E-074EBC0C6CAE}"/>
               </a:ext>
             </a:extLst>
           </p:cNvPr>
@@ -12018,7 +12018,7 @@
           <p:cNvPr id="30" name="s08-ablation-design-paired seeds-label">
             <a:extLst xmlns:a="http://schemas.openxmlformats.org/drawingml/2006/main">
               <a:ext uri="{FF2B5EF4-FFF2-40B4-BE49-F238E27FC236}">
-                <a16:creationId xmlns:a16="http://schemas.microsoft.com/office/drawing/2014/main" id="{1BE105CA-5B56-4F8E-BE03-D49A1AA8075B}"/>
+                <a16:creationId xmlns:a16="http://schemas.microsoft.com/office/drawing/2014/main" id="{2C275D92-9B3A-4BCF-A362-47C2758623A8}"/>
               </a:ext>
             </a:extLst>
           </p:cNvPr>
@@ -12066,7 +12066,7 @@
     </p:spTree>
     <p:extLst>
       <p:ext uri="{BB962C8B-B14F-4D97-AF65-F5344CB8AC3E}">
-        <p14:creationId xmlns:p14="http://schemas.microsoft.com/office/powerpoint/2010/main" val="1787235777"/>
+        <p14:creationId xmlns:p14="http://schemas.microsoft.com/office/powerpoint/2010/main" val="1001148317"/>
       </p:ext>
     </p:extLst>
   </p:cSld>
@@ -12097,7 +12097,7 @@
           <p:cNvPr id="14" name="top-rule-9">
             <a:extLst xmlns:a="http://schemas.openxmlformats.org/drawingml/2006/main">
               <a:ext uri="{FF2B5EF4-FFF2-40B4-BE49-F238E27FC236}">
-                <a16:creationId xmlns:a16="http://schemas.microsoft.com/office/drawing/2014/main" id="{0D3E4015-0794-4216-99A1-F7216EAACF2F}"/>
+                <a16:creationId xmlns:a16="http://schemas.microsoft.com/office/drawing/2014/main" id="{4BD4E863-F603-4D36-9651-F8AD20100811}"/>
               </a:ext>
             </a:extLst>
           </p:cNvPr>
@@ -12128,7 +12128,7 @@
           <p:cNvPr id="2" name="kicker-9">
             <a:extLst xmlns:a="http://schemas.openxmlformats.org/drawingml/2006/main">
               <a:ext uri="{FF2B5EF4-FFF2-40B4-BE49-F238E27FC236}">
-                <a16:creationId xmlns:a16="http://schemas.microsoft.com/office/drawing/2014/main" id="{8475D3FF-26D9-43D1-BA7D-834A666C9BA4}"/>
+                <a16:creationId xmlns:a16="http://schemas.microsoft.com/office/drawing/2014/main" id="{D6AB5D0C-A51A-4251-A001-3A5A0741EED8}"/>
               </a:ext>
             </a:extLst>
           </p:cNvPr>
@@ -12178,7 +12178,7 @@
           <p:cNvPr id="3" name="slide-title-9">
             <a:extLst xmlns:a="http://schemas.openxmlformats.org/drawingml/2006/main">
               <a:ext uri="{FF2B5EF4-FFF2-40B4-BE49-F238E27FC236}">
-                <a16:creationId xmlns:a16="http://schemas.microsoft.com/office/drawing/2014/main" id="{172951EC-8C09-4EDA-A966-EF43C787E053}"/>
+                <a16:creationId xmlns:a16="http://schemas.microsoft.com/office/drawing/2014/main" id="{78F00478-4899-4D24-B2E3-3E93061A06EF}"/>
               </a:ext>
             </a:extLst>
           </p:cNvPr>
@@ -12228,7 +12228,7 @@
           <p:cNvPr id="4" name="footer-rule-9">
             <a:extLst xmlns:a="http://schemas.openxmlformats.org/drawingml/2006/main">
               <a:ext uri="{FF2B5EF4-FFF2-40B4-BE49-F238E27FC236}">
-                <a16:creationId xmlns:a16="http://schemas.microsoft.com/office/drawing/2014/main" id="{24ECE4B7-4536-40A1-AAE6-EC5F0104C814}"/>
+                <a16:creationId xmlns:a16="http://schemas.microsoft.com/office/drawing/2014/main" id="{C6369AF8-3EAE-48CB-AF80-2E31BEF2019B}"/>
               </a:ext>
             </a:extLst>
           </p:cNvPr>
@@ -12259,7 +12259,7 @@
           <p:cNvPr id="5" name="evidence-9">
             <a:extLst xmlns:a="http://schemas.openxmlformats.org/drawingml/2006/main">
               <a:ext uri="{FF2B5EF4-FFF2-40B4-BE49-F238E27FC236}">
-                <a16:creationId xmlns:a16="http://schemas.microsoft.com/office/drawing/2014/main" id="{1CE29894-5301-4F74-AEC0-0B99C63AB6A5}"/>
+                <a16:creationId xmlns:a16="http://schemas.microsoft.com/office/drawing/2014/main" id="{4EE3D3AE-64D8-4EE9-879A-AAD944C6F35F}"/>
               </a:ext>
             </a:extLst>
           </p:cNvPr>
@@ -12309,7 +12309,7 @@
           <p:cNvPr id="6" name="page-9">
             <a:extLst xmlns:a="http://schemas.openxmlformats.org/drawingml/2006/main">
               <a:ext uri="{FF2B5EF4-FFF2-40B4-BE49-F238E27FC236}">
-                <a16:creationId xmlns:a16="http://schemas.microsoft.com/office/drawing/2014/main" id="{C7B2E0BC-6F86-40A0-8E9C-E7CEDBAA8DC7}"/>
+                <a16:creationId xmlns:a16="http://schemas.microsoft.com/office/drawing/2014/main" id="{4F7AF3F5-91AA-477E-BF45-A0E1C0824C23}"/>
               </a:ext>
             </a:extLst>
           </p:cNvPr>
@@ -12359,7 +12359,7 @@
           <p:cNvPr id="7" name="s09-negative-result-claim-mark">
             <a:extLst xmlns:a="http://schemas.openxmlformats.org/drawingml/2006/main">
               <a:ext uri="{FF2B5EF4-FFF2-40B4-BE49-F238E27FC236}">
-                <a16:creationId xmlns:a16="http://schemas.microsoft.com/office/drawing/2014/main" id="{B1671119-6657-4FAF-B28E-86E3C839CA84}"/>
+                <a16:creationId xmlns:a16="http://schemas.microsoft.com/office/drawing/2014/main" id="{F60169D6-7B7B-4CA9-A073-27A595B72E83}"/>
               </a:ext>
             </a:extLst>
           </p:cNvPr>
@@ -12390,7 +12390,7 @@
           <p:cNvPr id="8" name="s09-negative-result-claim">
             <a:extLst xmlns:a="http://schemas.openxmlformats.org/drawingml/2006/main">
               <a:ext uri="{FF2B5EF4-FFF2-40B4-BE49-F238E27FC236}">
-                <a16:creationId xmlns:a16="http://schemas.microsoft.com/office/drawing/2014/main" id="{DDD73EF0-BE4E-4A35-85C4-D2642DFD67CB}"/>
+                <a16:creationId xmlns:a16="http://schemas.microsoft.com/office/drawing/2014/main" id="{F784454D-68C5-4FAB-A8ED-28396F595845}"/>
               </a:ext>
             </a:extLst>
           </p:cNvPr>
@@ -12444,7 +12444,7 @@
           <p:nvPr/>
         </p:nvPicPr>
         <p:blipFill>
-          <a:blip xmlns:r="http://schemas.openxmlformats.org/officeDocument/2006/relationships" xmlns:a="http://schemas.openxmlformats.org/drawingml/2006/main" r:embed="R20358388a4084414"/>
+          <a:blip xmlns:r="http://schemas.openxmlformats.org/officeDocument/2006/relationships" xmlns:a="http://schemas.openxmlformats.org/drawingml/2006/main" r:embed="R7f7a337a3dc74562"/>
           <a:stretch xmlns:a="http://schemas.openxmlformats.org/drawingml/2006/main"/>
         </p:blipFill>
         <p:spPr>
@@ -12462,7 +12462,7 @@
           <p:cNvPr id="10" name="negative-gate">
             <a:extLst xmlns:a="http://schemas.openxmlformats.org/drawingml/2006/main">
               <a:ext uri="{FF2B5EF4-FFF2-40B4-BE49-F238E27FC236}">
-                <a16:creationId xmlns:a16="http://schemas.microsoft.com/office/drawing/2014/main" id="{B7FE01B8-0C98-4838-A956-4E3087A44ABD}"/>
+                <a16:creationId xmlns:a16="http://schemas.microsoft.com/office/drawing/2014/main" id="{554A00BF-A290-4131-88C7-DB8C42C3BE5D}"/>
               </a:ext>
             </a:extLst>
           </p:cNvPr>
@@ -12512,7 +12512,7 @@
           <p:cNvPr id="11" name="negative-dice">
             <a:extLst xmlns:a="http://schemas.openxmlformats.org/drawingml/2006/main">
               <a:ext uri="{FF2B5EF4-FFF2-40B4-BE49-F238E27FC236}">
-                <a16:creationId xmlns:a16="http://schemas.microsoft.com/office/drawing/2014/main" id="{4C876862-0DEA-43DD-8289-95761E65B281}"/>
+                <a16:creationId xmlns:a16="http://schemas.microsoft.com/office/drawing/2014/main" id="{916A2D1A-2DD7-45DC-9F5D-A1FE9B5DB12B}"/>
               </a:ext>
             </a:extLst>
           </p:cNvPr>
@@ -12579,7 +12579,7 @@
           <p:cNvPr id="12" name="negative-bf1">
             <a:extLst xmlns:a="http://schemas.openxmlformats.org/drawingml/2006/main">
               <a:ext uri="{FF2B5EF4-FFF2-40B4-BE49-F238E27FC236}">
-                <a16:creationId xmlns:a16="http://schemas.microsoft.com/office/drawing/2014/main" id="{87C90F85-E065-48E1-A1AF-54B9C6E97063}"/>
+                <a16:creationId xmlns:a16="http://schemas.microsoft.com/office/drawing/2014/main" id="{C249D70F-8347-4EBF-8BF1-D12441E63A3E}"/>
               </a:ext>
             </a:extLst>
           </p:cNvPr>
@@ -12646,7 +12646,7 @@
           <p:cNvPr id="13" name="negative-boundary">
             <a:extLst xmlns:a="http://schemas.openxmlformats.org/drawingml/2006/main">
               <a:ext uri="{FF2B5EF4-FFF2-40B4-BE49-F238E27FC236}">
-                <a16:creationId xmlns:a16="http://schemas.microsoft.com/office/drawing/2014/main" id="{42D1941B-5FBF-4C7D-9A89-95ACF161599A}"/>
+                <a16:creationId xmlns:a16="http://schemas.microsoft.com/office/drawing/2014/main" id="{7C68DA69-90E5-44D7-908E-BFE26AC5C60E}"/>
               </a:ext>
             </a:extLst>
           </p:cNvPr>
@@ -12694,7 +12694,7 @@
     </p:spTree>
     <p:extLst>
       <p:ext uri="{BB962C8B-B14F-4D97-AF65-F5344CB8AC3E}">
-        <p14:creationId xmlns:p14="http://schemas.microsoft.com/office/powerpoint/2010/main" val="1581377869"/>
+        <p14:creationId xmlns:p14="http://schemas.microsoft.com/office/powerpoint/2010/main" val="923835433"/>
       </p:ext>
     </p:extLst>
   </p:cSld>

</xml_diff>